<commit_message>
docs: deck demo and scoring images now come from the running app
Slide 4 shows two real screenshots of the running app answering exam
questions: the saved G3 (Anchorage) conversation and a G1 (New England)
conversation asked once in a session signed in through the access screen
with ACCESS_CODE, then reopened from the Recent chats rail. Slide 3 uses
the top of that page's rank_airports Evidence card (BOS 73.1 with Pillars
50.2 / 86.1 / 95.3) instead of the fixture-rendered BOS scorecard.
Slide 2 arrows are plain lines so LibreOffice renders them in place.

Co-Authored-By: Claude Opus 5.5 <noreply@anthropic.com>
</commit_message>
<xml_diff>
--- a/docs/deck.pptx
+++ b/docs/deck.pptx
@@ -5,14 +5,14 @@
     <p:sldMasterId xmlns:r="http://schemas.openxmlformats.org/officeDocument/2006/relationships" id="2147483648" r:id="rId1"/>
   </p:sldMasterIdLst>
   <p:notesMasterIdLst>
-    <p:notesMasterId r:id="R3ecd4a04b34849fa"/>
+    <p:notesMasterId r:id="R59c87c463d4143f0"/>
   </p:notesMasterIdLst>
   <p:sldIdLst>
-    <p:sldId id="256" r:id="R5408551f9cdd483e"/>
-    <p:sldId id="257" r:id="Rc3032bae47654521"/>
-    <p:sldId id="258" r:id="Rb8ad660123484203"/>
-    <p:sldId id="259" r:id="R6321538eb6364190"/>
-    <p:sldId id="260" r:id="Ra0b67b92a62f46e0"/>
+    <p:sldId id="256" r:id="R769172414a734919"/>
+    <p:sldId id="257" r:id="R30ef1c6438884a91"/>
+    <p:sldId id="258" r:id="Rdf9b474b4cdf4e66"/>
+    <p:sldId id="259" r:id="R6bdaac1b3dd64025"/>
+    <p:sldId id="260" r:id="Rf399fd65d57f4aa3"/>
   </p:sldIdLst>
   <p:sldSz cx="12192000" cy="6858000"/>
   <p:notesSz cx="6858000" cy="9144000"/>
@@ -585,7 +585,7 @@
           <a:p xmlns:a="http://schemas.openxmlformats.org/drawingml/2006/main">
             <a:r>
               <a:rPr lang="en-US"/>
-              <a:t>Each of seven metrics becomes a Percentile Score across the 402 Primary Airports, so a small airport compares with a large hub and outliers cannot stretch the scale. Pillars are weighted means of their metric percentiles. The Investment Opportunity Score is a weighted geometric mean of the Pillars, because the thesis is a conjunction: Martha's Vineyard has Demand Momentum 82.1 but Market Scale 28.4 and scores 54.7. A missing metric is imputed at the median and the score is labelled Provisional with the imputed metrics named. Data Confidence is computed from Coverage and recency, never judged by the model. The BOS scorecard on the right is the airport_scorecard Evidence card: Pillars 50.2, 86.1 and 95.3 give 73.1.</a:t>
+              <a:t>Each of seven metrics becomes a Percentile Score across the 402 Primary Airports, so a small airport compares with a large hub and outliers cannot stretch the scale. Pillars are weighted means of their metric percentiles. The Investment Opportunity Score is a weighted geometric mean of the Pillars, because the thesis is a conjunction: Martha's Vineyard has Demand Momentum 82.1 but Market Scale 28.4 and scores 54.7. A missing metric is imputed at the median and the score is labelled Provisional with the imputed metrics named. Data Confidence is computed from Coverage and recency, never judged by the model. On the right is the rank_airports Evidence card from the running app answering exam question G1 (New England): BOS has Pillars 50.2, 86.1 and 95.3 and scores 73.1.</a:t>
             </a:r>
           </a:p>
         </p:txBody>
@@ -640,7 +640,7 @@
           <a:p xmlns:a="http://schemas.openxmlformats.org/drawingml/2006/main">
             <a:r>
               <a:rPr lang="en-US"/>
-              <a:t>Left: the running app at 1440 by 900 in light theme, reopening a saved, verified conversation for exam question G3, the long-haul share at Anchorage. The answer leads with 2.7% of scheduled passenger departures, then the passenger-weighted 6.2% and cargo-inclusive 29.5% variants, with the 3,000-mile definition stated. The Mission panel shows the route_mix call and its Evidence: donuts and the table behind them, Data Confidence High. Right: the Pillar bars of the rank_airports Evidence card for G1, New England, rendered from the same tool result as the recorded answer: BOS 73.1, BGR 72.4, BTV 71.9.</a:t>
+              <a:t>Both screenshots are the running app at 1440 by 900 in light theme, reopening saved conversations from the Recent chats rail. Left, exam question G3: 2.7% of Anchorage's scheduled passenger departures are Long-haul Flights, with the passenger-weighted 6.2% and cargo-inclusive 29.5% variants and the 3,000-mile definition stated; the Mission panel shows the route_mix call and its donuts and table, Data Confidence High. Right, exam question G1: New England ranked by Investment Opportunity Score, BOS 73.1, BGR 72.4 and BTV 71.9 leading 16 ranked airports; the Mission panel shows the rank_airports call, the Pillar bars and the score table, Data Confidence Medium because HVN and PSM are Provisional.</a:t>
             </a:r>
           </a:p>
         </p:txBody>
@@ -2887,10 +2887,7 @@
       <p:cxnSp>
         <p:nvCxnSpPr>
           <p:cNvPr id="100050" name="Connector 1"/>
-          <p:cNvCxnSpPr>
-            <a:stCxn xmlns:a="http://schemas.openxmlformats.org/drawingml/2006/main" id="100034" idx="0"/>
-            <a:endCxn xmlns:a="http://schemas.openxmlformats.org/drawingml/2006/main" id="100038" idx="0"/>
-          </p:cNvCxnSpPr>
+          <p:cNvCxnSpPr/>
           <p:nvPr/>
         </p:nvCxnSpPr>
         <p:spPr>
@@ -2912,16 +2909,13 @@
       <p:cxnSp>
         <p:nvCxnSpPr>
           <p:cNvPr id="100051" name="Connector 2"/>
-          <p:cNvCxnSpPr>
-            <a:stCxn xmlns:a="http://schemas.openxmlformats.org/drawingml/2006/main" id="100038" idx="0"/>
-            <a:endCxn xmlns:a="http://schemas.openxmlformats.org/drawingml/2006/main" id="100042" idx="0"/>
-          </p:cNvCxnSpPr>
+          <p:cNvCxnSpPr/>
           <p:nvPr/>
         </p:nvCxnSpPr>
         <p:spPr>
           <a:xfrm xmlns:a="http://schemas.openxmlformats.org/drawingml/2006/main">
-            <a:off x="5898240" y="2988000"/>
-            <a:ext cx="395640" cy="0"/>
+            <a:off x="5897880" y="2988000"/>
+            <a:ext cx="396000" cy="0"/>
           </a:xfrm>
           <a:prstGeom xmlns:a="http://schemas.openxmlformats.org/drawingml/2006/main" prst="straightConnector1">
             <a:avLst/>
@@ -2937,10 +2931,7 @@
       <p:cxnSp>
         <p:nvCxnSpPr>
           <p:cNvPr id="100052" name="Connector 3"/>
-          <p:cNvCxnSpPr>
-            <a:stCxn xmlns:a="http://schemas.openxmlformats.org/drawingml/2006/main" id="100042" idx="0"/>
-            <a:endCxn xmlns:a="http://schemas.openxmlformats.org/drawingml/2006/main" id="100046" idx="0"/>
-          </p:cNvCxnSpPr>
+          <p:cNvCxnSpPr/>
           <p:nvPr/>
         </p:nvCxnSpPr>
         <p:spPr>
@@ -3674,7 +3665,7 @@
         <p:spPr>
           <a:xfrm xmlns:a="http://schemas.openxmlformats.org/drawingml/2006/main">
             <a:off x="540000" y="1512000"/>
-            <a:ext cx="7332120" cy="180000"/>
+            <a:ext cx="8268120" cy="180000"/>
           </a:xfrm>
           <a:prstGeom xmlns:a="http://schemas.openxmlformats.org/drawingml/2006/main" prst="rect">
             <a:avLst/>
@@ -3778,7 +3769,7 @@
         </p:nvSpPr>
         <p:spPr>
           <a:xfrm xmlns:a="http://schemas.openxmlformats.org/drawingml/2006/main">
-            <a:off x="6720120" y="1800000"/>
+            <a:off x="7656120" y="1800000"/>
             <a:ext cx="1152000" cy="288000"/>
           </a:xfrm>
           <a:prstGeom xmlns:a="http://schemas.openxmlformats.org/drawingml/2006/main" prst="rect">
@@ -3818,7 +3809,7 @@
         <p:spPr>
           <a:xfrm xmlns:a="http://schemas.openxmlformats.org/drawingml/2006/main">
             <a:off x="828000" y="2095200"/>
-            <a:ext cx="7044120" cy="432000"/>
+            <a:ext cx="7980120" cy="432000"/>
           </a:xfrm>
           <a:prstGeom xmlns:a="http://schemas.openxmlformats.org/drawingml/2006/main" prst="rect">
             <a:avLst/>
@@ -3922,7 +3913,7 @@
         </p:nvSpPr>
         <p:spPr>
           <a:xfrm xmlns:a="http://schemas.openxmlformats.org/drawingml/2006/main">
-            <a:off x="6720120" y="2610000"/>
+            <a:off x="7656120" y="2610000"/>
             <a:ext cx="1152000" cy="288000"/>
           </a:xfrm>
           <a:prstGeom xmlns:a="http://schemas.openxmlformats.org/drawingml/2006/main" prst="rect">
@@ -3962,7 +3953,7 @@
         <p:spPr>
           <a:xfrm xmlns:a="http://schemas.openxmlformats.org/drawingml/2006/main">
             <a:off x="828000" y="2905200"/>
-            <a:ext cx="7044120" cy="432000"/>
+            <a:ext cx="7980120" cy="432000"/>
           </a:xfrm>
           <a:prstGeom xmlns:a="http://schemas.openxmlformats.org/drawingml/2006/main" prst="rect">
             <a:avLst/>
@@ -4066,7 +4057,7 @@
         </p:nvSpPr>
         <p:spPr>
           <a:xfrm xmlns:a="http://schemas.openxmlformats.org/drawingml/2006/main">
-            <a:off x="6720120" y="3420000"/>
+            <a:off x="7656120" y="3420000"/>
             <a:ext cx="1152000" cy="288000"/>
           </a:xfrm>
           <a:prstGeom xmlns:a="http://schemas.openxmlformats.org/drawingml/2006/main" prst="rect">
@@ -4106,7 +4097,7 @@
         <p:spPr>
           <a:xfrm xmlns:a="http://schemas.openxmlformats.org/drawingml/2006/main">
             <a:off x="828000" y="3715200"/>
-            <a:ext cx="7044120" cy="432000"/>
+            <a:ext cx="7980120" cy="432000"/>
           </a:xfrm>
           <a:prstGeom xmlns:a="http://schemas.openxmlformats.org/drawingml/2006/main" prst="rect">
             <a:avLst/>
@@ -4145,7 +4136,7 @@
         <p:spPr>
           <a:xfrm xmlns:a="http://schemas.openxmlformats.org/drawingml/2006/main">
             <a:off x="540000" y="4104000"/>
-            <a:ext cx="7332120" cy="1062000"/>
+            <a:ext cx="8268120" cy="1062000"/>
           </a:xfrm>
           <a:prstGeom xmlns:a="http://schemas.openxmlformats.org/drawingml/2006/main" prst="rect">
             <a:avLst/>
@@ -4174,7 +4165,7 @@
         <p:spPr>
           <a:xfrm xmlns:a="http://schemas.openxmlformats.org/drawingml/2006/main">
             <a:off x="756000" y="4212000"/>
-            <a:ext cx="6900120" cy="180000"/>
+            <a:ext cx="7836120" cy="180000"/>
           </a:xfrm>
           <a:prstGeom xmlns:a="http://schemas.openxmlformats.org/drawingml/2006/main" prst="rect">
             <a:avLst/>
@@ -4213,7 +4204,7 @@
         <p:spPr>
           <a:xfrm xmlns:a="http://schemas.openxmlformats.org/drawingml/2006/main">
             <a:off x="756000" y="4410000"/>
-            <a:ext cx="6900120" cy="324000"/>
+            <a:ext cx="7836120" cy="324000"/>
           </a:xfrm>
           <a:prstGeom xmlns:a="http://schemas.openxmlformats.org/drawingml/2006/main" prst="rect">
             <a:avLst/>
@@ -4252,7 +4243,7 @@
         <p:spPr>
           <a:xfrm xmlns:a="http://schemas.openxmlformats.org/drawingml/2006/main">
             <a:off x="756000" y="4716000"/>
-            <a:ext cx="6900120" cy="414000"/>
+            <a:ext cx="7836120" cy="414000"/>
           </a:xfrm>
           <a:prstGeom xmlns:a="http://schemas.openxmlformats.org/drawingml/2006/main" prst="rect">
             <a:avLst/>
@@ -4290,8 +4281,8 @@
         </p:nvSpPr>
         <p:spPr>
           <a:xfrm xmlns:a="http://schemas.openxmlformats.org/drawingml/2006/main">
-            <a:off x="8178120" y="1494000"/>
-            <a:ext cx="3492000" cy="3280320"/>
+            <a:off x="9114120" y="1494000"/>
+            <a:ext cx="2556000" cy="4289760"/>
           </a:xfrm>
           <a:prstGeom xmlns:a="http://schemas.openxmlformats.org/drawingml/2006/main" prst="rect">
             <a:avLst/>
@@ -4313,22 +4304,22 @@
       </p:sp>
       <p:pic>
         <p:nvPicPr>
-          <p:cNvPr id="100091" name="Picture 1" descr="BOS scorecard Evidence card: Investment Opportunity Score 73.1, national rank 11 of 399, Pillar bars Demand Momentum 50.2, Capacity Pressure 86.1, Market Scale 95.3"/>
+          <p:cNvPr id="100091" name="Picture 1" descr="rank_airports Evidence card in the running app for New England: Pillar bars per airport against the median (50), and BOS first with score 73.1 and Pillars 50.2, 86.1, 95.3"/>
           <p:cNvPicPr>
             <a:picLocks xmlns:a="http://schemas.openxmlformats.org/drawingml/2006/main" noChangeAspect="1"/>
           </p:cNvPicPr>
           <p:nvPr/>
         </p:nvPicPr>
         <p:blipFill>
-          <a:blip xmlns:r="http://schemas.openxmlformats.org/officeDocument/2006/relationships" xmlns:a="http://schemas.openxmlformats.org/drawingml/2006/main" r:embed="Refcaa8de54cb43ee"/>
+          <a:blip xmlns:r="http://schemas.openxmlformats.org/officeDocument/2006/relationships" xmlns:a="http://schemas.openxmlformats.org/drawingml/2006/main" r:embed="R7d6df98475a44205"/>
           <a:stretch xmlns:a="http://schemas.openxmlformats.org/drawingml/2006/main">
             <a:fillRect/>
           </a:stretch>
         </p:blipFill>
         <p:spPr>
           <a:xfrm xmlns:a="http://schemas.openxmlformats.org/drawingml/2006/main">
-            <a:off x="8196120" y="1512000"/>
-            <a:ext cx="3456000" cy="3244320"/>
+            <a:off x="9132120" y="1512000"/>
+            <a:ext cx="2520000" cy="4253760"/>
           </a:xfrm>
           <a:prstGeom xmlns:a="http://schemas.openxmlformats.org/drawingml/2006/main" prst="rect">
             <a:avLst/>
@@ -4343,8 +4334,8 @@
         </p:nvSpPr>
         <p:spPr>
           <a:xfrm xmlns:a="http://schemas.openxmlformats.org/drawingml/2006/main">
-            <a:off x="8196120" y="4846320"/>
-            <a:ext cx="3456000" cy="540000"/>
+            <a:off x="9132120" y="5837760"/>
+            <a:ext cx="2520000" cy="576000"/>
           </a:xfrm>
           <a:prstGeom xmlns:a="http://schemas.openxmlformats.org/drawingml/2006/main" prst="rect">
             <a:avLst/>
@@ -4369,7 +4360,7 @@
                 <a:latin typeface="Arial"/>
                 <a:ea typeface="Arial"/>
               </a:rPr>
-              <a:t>airport_scorecard Evidence for BOS: Pillars 50.2 / 86.1 / 95.3 give 73.1, national rank 11 of 399.</a:t>
+              <a:t>Running app, G1 Mission panel: BOS Pillars 50.2 / 86.1 / 95.3 give 73.1.</a:t>
             </a:r>
           </a:p>
         </p:txBody>
@@ -4382,8 +4373,8 @@
         </p:nvSpPr>
         <p:spPr>
           <a:xfrm xmlns:a="http://schemas.openxmlformats.org/drawingml/2006/main">
-            <a:off x="540000" y="5400000"/>
-            <a:ext cx="3521520" cy="180000"/>
+            <a:off x="540000" y="5328000"/>
+            <a:ext cx="2612160" cy="180000"/>
           </a:xfrm>
           <a:prstGeom xmlns:a="http://schemas.openxmlformats.org/drawingml/2006/main" prst="rect">
             <a:avLst/>
@@ -4421,26 +4412,26 @@
         </p:nvSpPr>
         <p:spPr>
           <a:xfrm xmlns:a="http://schemas.openxmlformats.org/drawingml/2006/main">
-            <a:off x="540000" y="5598000"/>
-            <a:ext cx="3521520" cy="828000"/>
-          </a:xfrm>
-          <a:prstGeom xmlns:a="http://schemas.openxmlformats.org/drawingml/2006/main" prst="rect">
-            <a:avLst/>
-          </a:prstGeom>
-          <a:noFill xmlns:a="http://schemas.openxmlformats.org/drawingml/2006/main"/>
-          <a:ln xmlns:a="http://schemas.openxmlformats.org/drawingml/2006/main">
-            <a:noFill/>
-          </a:ln>
-        </p:spPr>
-        <p:txBody>
-          <a:bodyPr xmlns:a="http://schemas.openxmlformats.org/drawingml/2006/main" lIns="0" tIns="0" rIns="0" bIns="0" anchor="t">
-            <a:noAutofit/>
-          </a:bodyPr>
-          <a:lstStyle xmlns:a="http://schemas.openxmlformats.org/drawingml/2006/main"/>
-          <a:p xmlns:a="http://schemas.openxmlformats.org/drawingml/2006/main">
-            <a:pPr algn="l"/>
-            <a:r>
-              <a:rPr lang="en-US" sz="1400" b="0">
+            <a:off x="540000" y="5526000"/>
+            <a:ext cx="2612160" cy="900000"/>
+          </a:xfrm>
+          <a:prstGeom xmlns:a="http://schemas.openxmlformats.org/drawingml/2006/main" prst="rect">
+            <a:avLst/>
+          </a:prstGeom>
+          <a:noFill xmlns:a="http://schemas.openxmlformats.org/drawingml/2006/main"/>
+          <a:ln xmlns:a="http://schemas.openxmlformats.org/drawingml/2006/main">
+            <a:noFill/>
+          </a:ln>
+        </p:spPr>
+        <p:txBody>
+          <a:bodyPr xmlns:a="http://schemas.openxmlformats.org/drawingml/2006/main" lIns="0" tIns="0" rIns="0" bIns="0" anchor="t">
+            <a:noAutofit/>
+          </a:bodyPr>
+          <a:lstStyle xmlns:a="http://schemas.openxmlformats.org/drawingml/2006/main"/>
+          <a:p xmlns:a="http://schemas.openxmlformats.org/drawingml/2006/main">
+            <a:pPr algn="l"/>
+            <a:r>
+              <a:rPr lang="en-US" sz="1300" b="0">
                 <a:solidFill>
                   <a:srgbClr val="1B1A17"/>
                 </a:solidFill>
@@ -4460,8 +4451,8 @@
         </p:nvSpPr>
         <p:spPr>
           <a:xfrm xmlns:a="http://schemas.openxmlformats.org/drawingml/2006/main">
-            <a:off x="4335120" y="5400000"/>
-            <a:ext cx="3521520" cy="180000"/>
+            <a:off x="3368160" y="5328000"/>
+            <a:ext cx="2612160" cy="180000"/>
           </a:xfrm>
           <a:prstGeom xmlns:a="http://schemas.openxmlformats.org/drawingml/2006/main" prst="rect">
             <a:avLst/>
@@ -4499,26 +4490,26 @@
         </p:nvSpPr>
         <p:spPr>
           <a:xfrm xmlns:a="http://schemas.openxmlformats.org/drawingml/2006/main">
-            <a:off x="4335120" y="5598000"/>
-            <a:ext cx="3521520" cy="828000"/>
-          </a:xfrm>
-          <a:prstGeom xmlns:a="http://schemas.openxmlformats.org/drawingml/2006/main" prst="rect">
-            <a:avLst/>
-          </a:prstGeom>
-          <a:noFill xmlns:a="http://schemas.openxmlformats.org/drawingml/2006/main"/>
-          <a:ln xmlns:a="http://schemas.openxmlformats.org/drawingml/2006/main">
-            <a:noFill/>
-          </a:ln>
-        </p:spPr>
-        <p:txBody>
-          <a:bodyPr xmlns:a="http://schemas.openxmlformats.org/drawingml/2006/main" lIns="0" tIns="0" rIns="0" bIns="0" anchor="t">
-            <a:noAutofit/>
-          </a:bodyPr>
-          <a:lstStyle xmlns:a="http://schemas.openxmlformats.org/drawingml/2006/main"/>
-          <a:p xmlns:a="http://schemas.openxmlformats.org/drawingml/2006/main">
-            <a:pPr algn="l"/>
-            <a:r>
-              <a:rPr lang="en-US" sz="1400" b="0">
+            <a:off x="3368160" y="5526000"/>
+            <a:ext cx="2612160" cy="900000"/>
+          </a:xfrm>
+          <a:prstGeom xmlns:a="http://schemas.openxmlformats.org/drawingml/2006/main" prst="rect">
+            <a:avLst/>
+          </a:prstGeom>
+          <a:noFill xmlns:a="http://schemas.openxmlformats.org/drawingml/2006/main"/>
+          <a:ln xmlns:a="http://schemas.openxmlformats.org/drawingml/2006/main">
+            <a:noFill/>
+          </a:ln>
+        </p:spPr>
+        <p:txBody>
+          <a:bodyPr xmlns:a="http://schemas.openxmlformats.org/drawingml/2006/main" lIns="0" tIns="0" rIns="0" bIns="0" anchor="t">
+            <a:noAutofit/>
+          </a:bodyPr>
+          <a:lstStyle xmlns:a="http://schemas.openxmlformats.org/drawingml/2006/main"/>
+          <a:p xmlns:a="http://schemas.openxmlformats.org/drawingml/2006/main">
+            <a:pPr algn="l"/>
+            <a:r>
+              <a:rPr lang="en-US" sz="1300" b="0">
                 <a:solidFill>
                   <a:srgbClr val="1B1A17"/>
                 </a:solidFill>
@@ -4538,8 +4529,8 @@
         </p:nvSpPr>
         <p:spPr>
           <a:xfrm xmlns:a="http://schemas.openxmlformats.org/drawingml/2006/main">
-            <a:off x="8130600" y="5400000"/>
-            <a:ext cx="3521520" cy="180000"/>
+            <a:off x="6195960" y="5328000"/>
+            <a:ext cx="2612160" cy="180000"/>
           </a:xfrm>
           <a:prstGeom xmlns:a="http://schemas.openxmlformats.org/drawingml/2006/main" prst="rect">
             <a:avLst/>
@@ -4577,26 +4568,26 @@
         </p:nvSpPr>
         <p:spPr>
           <a:xfrm xmlns:a="http://schemas.openxmlformats.org/drawingml/2006/main">
-            <a:off x="8130600" y="5598000"/>
-            <a:ext cx="3521520" cy="828000"/>
-          </a:xfrm>
-          <a:prstGeom xmlns:a="http://schemas.openxmlformats.org/drawingml/2006/main" prst="rect">
-            <a:avLst/>
-          </a:prstGeom>
-          <a:noFill xmlns:a="http://schemas.openxmlformats.org/drawingml/2006/main"/>
-          <a:ln xmlns:a="http://schemas.openxmlformats.org/drawingml/2006/main">
-            <a:noFill/>
-          </a:ln>
-        </p:spPr>
-        <p:txBody>
-          <a:bodyPr xmlns:a="http://schemas.openxmlformats.org/drawingml/2006/main" lIns="0" tIns="0" rIns="0" bIns="0" anchor="t">
-            <a:noAutofit/>
-          </a:bodyPr>
-          <a:lstStyle xmlns:a="http://schemas.openxmlformats.org/drawingml/2006/main"/>
-          <a:p xmlns:a="http://schemas.openxmlformats.org/drawingml/2006/main">
-            <a:pPr algn="l"/>
-            <a:r>
-              <a:rPr lang="en-US" sz="1400" b="0">
+            <a:off x="6195960" y="5526000"/>
+            <a:ext cx="2612160" cy="900000"/>
+          </a:xfrm>
+          <a:prstGeom xmlns:a="http://schemas.openxmlformats.org/drawingml/2006/main" prst="rect">
+            <a:avLst/>
+          </a:prstGeom>
+          <a:noFill xmlns:a="http://schemas.openxmlformats.org/drawingml/2006/main"/>
+          <a:ln xmlns:a="http://schemas.openxmlformats.org/drawingml/2006/main">
+            <a:noFill/>
+          </a:ln>
+        </p:spPr>
+        <p:txBody>
+          <a:bodyPr xmlns:a="http://schemas.openxmlformats.org/drawingml/2006/main" lIns="0" tIns="0" rIns="0" bIns="0" anchor="t">
+            <a:noAutofit/>
+          </a:bodyPr>
+          <a:lstStyle xmlns:a="http://schemas.openxmlformats.org/drawingml/2006/main"/>
+          <a:p xmlns:a="http://schemas.openxmlformats.org/drawingml/2006/main">
+            <a:pPr algn="l"/>
+            <a:r>
+              <a:rPr lang="en-US" sz="1300" b="0">
                 <a:solidFill>
                   <a:srgbClr val="1B1A17"/>
                 </a:solidFill>
@@ -4830,14 +4821,53 @@
       </p:sp>
       <p:sp>
         <p:nvSpPr>
-          <p:cNvPr id="100105" name="AppFrame"/>
+          <p:cNvPr id="100105" name="ShotLab1"/>
+          <p:cNvSpPr txBox="1"/>
+          <p:nvPr/>
+        </p:nvSpPr>
+        <p:spPr>
+          <a:xfrm xmlns:a="http://schemas.openxmlformats.org/drawingml/2006/main">
+            <a:off x="540000" y="1512000"/>
+            <a:ext cx="5411880" cy="180000"/>
+          </a:xfrm>
+          <a:prstGeom xmlns:a="http://schemas.openxmlformats.org/drawingml/2006/main" prst="rect">
+            <a:avLst/>
+          </a:prstGeom>
+          <a:noFill xmlns:a="http://schemas.openxmlformats.org/drawingml/2006/main"/>
+          <a:ln xmlns:a="http://schemas.openxmlformats.org/drawingml/2006/main">
+            <a:noFill/>
+          </a:ln>
+        </p:spPr>
+        <p:txBody>
+          <a:bodyPr xmlns:a="http://schemas.openxmlformats.org/drawingml/2006/main" lIns="0" tIns="0" rIns="0" bIns="0" anchor="t">
+            <a:noAutofit/>
+          </a:bodyPr>
+          <a:lstStyle xmlns:a="http://schemas.openxmlformats.org/drawingml/2006/main"/>
+          <a:p xmlns:a="http://schemas.openxmlformats.org/drawingml/2006/main">
+            <a:pPr algn="l"/>
+            <a:r>
+              <a:rPr lang="en-US" sz="1100" b="0">
+                <a:solidFill>
+                  <a:srgbClr val="66645E"/>
+                </a:solidFill>
+                <a:latin typeface="Consolas"/>
+                <a:ea typeface="Consolas"/>
+              </a:rPr>
+              <a:t>G3 · ANCHORAGE LONG-HAUL SHARE</a:t>
+            </a:r>
+          </a:p>
+        </p:txBody>
+      </p:sp>
+      <p:sp>
+        <p:nvSpPr>
+          <p:cNvPr id="100106" name="AppFrame1"/>
           <p:cNvSpPr/>
           <p:nvPr/>
         </p:nvSpPr>
         <p:spPr>
           <a:xfrm xmlns:a="http://schemas.openxmlformats.org/drawingml/2006/main">
-            <a:off x="522000" y="1458000"/>
-            <a:ext cx="6876000" cy="4311000"/>
+            <a:off x="522000" y="1746000"/>
+            <a:ext cx="5447880" cy="3418560"/>
           </a:xfrm>
           <a:prstGeom xmlns:a="http://schemas.openxmlformats.org/drawingml/2006/main" prst="rect">
             <a:avLst/>
@@ -4859,22 +4889,22 @@
       </p:sp>
       <p:pic>
         <p:nvPicPr>
-          <p:cNvPr id="100106" name="Picture 1" descr="The running app answering 'What is the percentage of long haul flights out of Anchorage airport?': 2.7% of class F departures are Long-haul Flights; the Mission panel shows route_mix donuts at 2.7%, 6.2% and 29.5% and Data Confidence High"/>
+          <p:cNvPr id="100107" name="Picture 1" descr="The running app answering 'What is the percentage of long haul flights out of Anchorage airport?': 2.7% of class F departures are Long-haul Flights; the Mission panel shows route_mix donuts at 2.7%, 6.2% and 29.5% and Data Confidence High"/>
           <p:cNvPicPr>
             <a:picLocks xmlns:a="http://schemas.openxmlformats.org/drawingml/2006/main" noChangeAspect="1"/>
           </p:cNvPicPr>
           <p:nvPr/>
         </p:nvPicPr>
         <p:blipFill>
-          <a:blip xmlns:r="http://schemas.openxmlformats.org/officeDocument/2006/relationships" xmlns:a="http://schemas.openxmlformats.org/drawingml/2006/main" r:embed="R99a42af3f24941f0"/>
+          <a:blip xmlns:r="http://schemas.openxmlformats.org/officeDocument/2006/relationships" xmlns:a="http://schemas.openxmlformats.org/drawingml/2006/main" r:embed="R84c46bf5a4824fda"/>
           <a:stretch xmlns:a="http://schemas.openxmlformats.org/drawingml/2006/main">
             <a:fillRect/>
           </a:stretch>
         </p:blipFill>
         <p:spPr>
           <a:xfrm xmlns:a="http://schemas.openxmlformats.org/drawingml/2006/main">
-            <a:off x="540000" y="1476000"/>
-            <a:ext cx="6840000" cy="4275000"/>
+            <a:off x="540000" y="1764000"/>
+            <a:ext cx="5411880" cy="3382560"/>
           </a:xfrm>
           <a:prstGeom xmlns:a="http://schemas.openxmlformats.org/drawingml/2006/main" prst="rect">
             <a:avLst/>
@@ -4883,53 +4913,53 @@
       </p:pic>
       <p:sp>
         <p:nvSpPr>
-          <p:cNvPr id="100107" name="AppCap"/>
-          <p:cNvSpPr txBox="1"/>
-          <p:nvPr/>
-        </p:nvSpPr>
-        <p:spPr>
-          <a:xfrm xmlns:a="http://schemas.openxmlformats.org/drawingml/2006/main">
-            <a:off x="540000" y="5841000"/>
-            <a:ext cx="6840000" cy="540000"/>
-          </a:xfrm>
-          <a:prstGeom xmlns:a="http://schemas.openxmlformats.org/drawingml/2006/main" prst="rect">
-            <a:avLst/>
-          </a:prstGeom>
-          <a:noFill xmlns:a="http://schemas.openxmlformats.org/drawingml/2006/main"/>
-          <a:ln xmlns:a="http://schemas.openxmlformats.org/drawingml/2006/main">
-            <a:noFill/>
-          </a:ln>
-        </p:spPr>
-        <p:txBody>
-          <a:bodyPr xmlns:a="http://schemas.openxmlformats.org/drawingml/2006/main" lIns="0" tIns="0" rIns="0" bIns="0" anchor="t">
-            <a:noAutofit/>
-          </a:bodyPr>
-          <a:lstStyle xmlns:a="http://schemas.openxmlformats.org/drawingml/2006/main"/>
-          <a:p xmlns:a="http://schemas.openxmlformats.org/drawingml/2006/main">
-            <a:pPr algn="l"/>
-            <a:r>
-              <a:rPr lang="en-US" sz="1200" b="0">
-                <a:solidFill>
-                  <a:srgbClr val="66645E"/>
+          <p:cNvPr id="100108" name="ShotCap1"/>
+          <p:cNvSpPr txBox="1"/>
+          <p:nvPr/>
+        </p:nvSpPr>
+        <p:spPr>
+          <a:xfrm xmlns:a="http://schemas.openxmlformats.org/drawingml/2006/main">
+            <a:off x="540000" y="5272560"/>
+            <a:ext cx="5411880" cy="864000"/>
+          </a:xfrm>
+          <a:prstGeom xmlns:a="http://schemas.openxmlformats.org/drawingml/2006/main" prst="rect">
+            <a:avLst/>
+          </a:prstGeom>
+          <a:noFill xmlns:a="http://schemas.openxmlformats.org/drawingml/2006/main"/>
+          <a:ln xmlns:a="http://schemas.openxmlformats.org/drawingml/2006/main">
+            <a:noFill/>
+          </a:ln>
+        </p:spPr>
+        <p:txBody>
+          <a:bodyPr xmlns:a="http://schemas.openxmlformats.org/drawingml/2006/main" lIns="0" tIns="0" rIns="0" bIns="0" anchor="t">
+            <a:noAutofit/>
+          </a:bodyPr>
+          <a:lstStyle xmlns:a="http://schemas.openxmlformats.org/drawingml/2006/main"/>
+          <a:p xmlns:a="http://schemas.openxmlformats.org/drawingml/2006/main">
+            <a:pPr algn="l"/>
+            <a:r>
+              <a:rPr lang="en-US" sz="1400" b="0">
+                <a:solidFill>
+                  <a:srgbClr val="1B1A17"/>
                 </a:solidFill>
                 <a:latin typeface="Arial"/>
                 <a:ea typeface="Arial"/>
               </a:rPr>
-              <a:t>G3 · Anchorage: 2.7% of scheduled passenger departures are Long-haul (6.2% passenger-weighted, 29.5% cargo-inclusive); route_mix Evidence in the Mission panel.</a:t>
-            </a:r>
-          </a:p>
-        </p:txBody>
-      </p:sp>
-      <p:sp>
-        <p:nvSpPr>
-          <p:cNvPr id="100108" name="RLabel"/>
-          <p:cNvSpPr txBox="1"/>
-          <p:nvPr/>
-        </p:nvSpPr>
-        <p:spPr>
-          <a:xfrm xmlns:a="http://schemas.openxmlformats.org/drawingml/2006/main">
-            <a:off x="7740000" y="1476000"/>
-            <a:ext cx="3912120" cy="180000"/>
+              <a:t>2.7% of scheduled passenger departures are Long-haul (6.2% passenger-weighted, 29.5% cargo-inclusive). Mission panel: route_mix donuts and table, Data Confidence High.</a:t>
+            </a:r>
+          </a:p>
+        </p:txBody>
+      </p:sp>
+      <p:sp>
+        <p:nvSpPr>
+          <p:cNvPr id="100109" name="ShotLab2"/>
+          <p:cNvSpPr txBox="1"/>
+          <p:nvPr/>
+        </p:nvSpPr>
+        <p:spPr>
+          <a:xfrm xmlns:a="http://schemas.openxmlformats.org/drawingml/2006/main">
+            <a:off x="6240240" y="1512000"/>
+            <a:ext cx="5411880" cy="180000"/>
           </a:xfrm>
           <a:prstGeom xmlns:a="http://schemas.openxmlformats.org/drawingml/2006/main" prst="rect">
             <a:avLst/>
@@ -4961,14 +4991,14 @@
       </p:sp>
       <p:sp>
         <p:nvSpPr>
-          <p:cNvPr id="100109" name="RankFrame"/>
+          <p:cNvPr id="100110" name="AppFrame2"/>
           <p:cNvSpPr/>
           <p:nvPr/>
         </p:nvSpPr>
         <p:spPr>
           <a:xfrm xmlns:a="http://schemas.openxmlformats.org/drawingml/2006/main">
-            <a:off x="7722000" y="1710000"/>
-            <a:ext cx="2505240" cy="3492000"/>
+            <a:off x="6222240" y="1746000"/>
+            <a:ext cx="5447880" cy="3418560"/>
           </a:xfrm>
           <a:prstGeom xmlns:a="http://schemas.openxmlformats.org/drawingml/2006/main" prst="rect">
             <a:avLst/>
@@ -4990,22 +5020,22 @@
       </p:sp>
       <p:pic>
         <p:nvPicPr>
-          <p:cNvPr id="100110" name="Picture 2" descr="rank_airports Evidence card for New England: Pillar bars per airport for BOS, BGR, BTV, HVN, PWM, PVD, PSM, BDL, MVY and MHT against the median (50)"/>
+          <p:cNvPr id="100111" name="Picture 2" descr="The running app answering 'Which airports in New England are strong candidates for terminal expansion?': a ranking table led by BOS 73.1, BGR 72.4 and BTV 71.9; the Mission panel shows rank_airports Pillar bars and the score table, Data Confidence Medium"/>
           <p:cNvPicPr>
             <a:picLocks xmlns:a="http://schemas.openxmlformats.org/drawingml/2006/main" noChangeAspect="1"/>
           </p:cNvPicPr>
           <p:nvPr/>
         </p:nvPicPr>
         <p:blipFill>
-          <a:blip xmlns:r="http://schemas.openxmlformats.org/officeDocument/2006/relationships" xmlns:a="http://schemas.openxmlformats.org/drawingml/2006/main" r:embed="Rb12a8d4ec6204338"/>
+          <a:blip xmlns:r="http://schemas.openxmlformats.org/officeDocument/2006/relationships" xmlns:a="http://schemas.openxmlformats.org/drawingml/2006/main" r:embed="Re59852e05e7f4120"/>
           <a:stretch xmlns:a="http://schemas.openxmlformats.org/drawingml/2006/main">
             <a:fillRect/>
           </a:stretch>
         </p:blipFill>
         <p:spPr>
           <a:xfrm xmlns:a="http://schemas.openxmlformats.org/drawingml/2006/main">
-            <a:off x="7740000" y="1728000"/>
-            <a:ext cx="2469240" cy="3456000"/>
+            <a:off x="6240240" y="1764000"/>
+            <a:ext cx="5411880" cy="3382560"/>
           </a:xfrm>
           <a:prstGeom xmlns:a="http://schemas.openxmlformats.org/drawingml/2006/main" prst="rect">
             <a:avLst/>
@@ -5014,39 +5044,39 @@
       </p:pic>
       <p:sp>
         <p:nvSpPr>
-          <p:cNvPr id="100111" name="RankCap"/>
-          <p:cNvSpPr txBox="1"/>
-          <p:nvPr/>
-        </p:nvSpPr>
-        <p:spPr>
-          <a:xfrm xmlns:a="http://schemas.openxmlformats.org/drawingml/2006/main">
-            <a:off x="7740000" y="5292000"/>
-            <a:ext cx="3912120" cy="936000"/>
-          </a:xfrm>
-          <a:prstGeom xmlns:a="http://schemas.openxmlformats.org/drawingml/2006/main" prst="rect">
-            <a:avLst/>
-          </a:prstGeom>
-          <a:noFill xmlns:a="http://schemas.openxmlformats.org/drawingml/2006/main"/>
-          <a:ln xmlns:a="http://schemas.openxmlformats.org/drawingml/2006/main">
-            <a:noFill/>
-          </a:ln>
-        </p:spPr>
-        <p:txBody>
-          <a:bodyPr xmlns:a="http://schemas.openxmlformats.org/drawingml/2006/main" lIns="0" tIns="0" rIns="0" bIns="0" anchor="t">
-            <a:noAutofit/>
-          </a:bodyPr>
-          <a:lstStyle xmlns:a="http://schemas.openxmlformats.org/drawingml/2006/main"/>
-          <a:p xmlns:a="http://schemas.openxmlformats.org/drawingml/2006/main">
-            <a:pPr algn="l"/>
-            <a:r>
-              <a:rPr lang="en-US" sz="1200" b="0">
-                <a:solidFill>
-                  <a:srgbClr val="66645E"/>
+          <p:cNvPr id="100112" name="ShotCap2"/>
+          <p:cNvSpPr txBox="1"/>
+          <p:nvPr/>
+        </p:nvSpPr>
+        <p:spPr>
+          <a:xfrm xmlns:a="http://schemas.openxmlformats.org/drawingml/2006/main">
+            <a:off x="6240240" y="5272560"/>
+            <a:ext cx="5411880" cy="864000"/>
+          </a:xfrm>
+          <a:prstGeom xmlns:a="http://schemas.openxmlformats.org/drawingml/2006/main" prst="rect">
+            <a:avLst/>
+          </a:prstGeom>
+          <a:noFill xmlns:a="http://schemas.openxmlformats.org/drawingml/2006/main"/>
+          <a:ln xmlns:a="http://schemas.openxmlformats.org/drawingml/2006/main">
+            <a:noFill/>
+          </a:ln>
+        </p:spPr>
+        <p:txBody>
+          <a:bodyPr xmlns:a="http://schemas.openxmlformats.org/drawingml/2006/main" lIns="0" tIns="0" rIns="0" bIns="0" anchor="t">
+            <a:noAutofit/>
+          </a:bodyPr>
+          <a:lstStyle xmlns:a="http://schemas.openxmlformats.org/drawingml/2006/main"/>
+          <a:p xmlns:a="http://schemas.openxmlformats.org/drawingml/2006/main">
+            <a:pPr algn="l"/>
+            <a:r>
+              <a:rPr lang="en-US" sz="1400" b="0">
+                <a:solidFill>
+                  <a:srgbClr val="1B1A17"/>
                 </a:solidFill>
                 <a:latin typeface="Arial"/>
                 <a:ea typeface="Arial"/>
               </a:rPr>
-              <a:t>“Which airports in New England are strong candidates for terminal expansion?” Pillar bars from the rank_airports Evidence card, rendered from the same tool result: BOS 73.1, BGR 72.4 and BTV 71.9 lead 16 ranked airports.</a:t>
+              <a:t>BOS 73.1, BGR 72.4 and BTV 71.9 lead 16 ranked airports. Mission panel: rank_airports Pillar bars and score table, Data Confidence Medium (HVN and PSM Provisional).</a:t>
             </a:r>
           </a:p>
         </p:txBody>
@@ -5075,7 +5105,7 @@
       <p:grpSpPr/>
       <p:sp>
         <p:nvSpPr>
-          <p:cNvPr id="100112" name="Eyebrow"/>
+          <p:cNvPr id="100113" name="Eyebrow"/>
           <p:cNvSpPr txBox="1"/>
           <p:nvPr/>
         </p:nvSpPr>
@@ -5114,7 +5144,7 @@
       </p:sp>
       <p:sp>
         <p:nvSpPr>
-          <p:cNvPr id="100113" name="Motif1"/>
+          <p:cNvPr id="100114" name="Motif1"/>
           <p:cNvSpPr/>
           <p:nvPr/>
         </p:nvSpPr>
@@ -5141,7 +5171,7 @@
       </p:sp>
       <p:sp>
         <p:nvSpPr>
-          <p:cNvPr id="100114" name="Motif2"/>
+          <p:cNvPr id="100115" name="Motif2"/>
           <p:cNvSpPr/>
           <p:nvPr/>
         </p:nvSpPr>
@@ -5168,7 +5198,7 @@
       </p:sp>
       <p:sp>
         <p:nvSpPr>
-          <p:cNvPr id="100115" name="Motif3"/>
+          <p:cNvPr id="100116" name="Motif3"/>
           <p:cNvSpPr/>
           <p:nvPr/>
         </p:nvSpPr>
@@ -5195,7 +5225,7 @@
       </p:sp>
       <p:sp>
         <p:nvSpPr>
-          <p:cNvPr id="100116" name="Title"/>
+          <p:cNvPr id="100117" name="Title"/>
           <p:cNvSpPr txBox="1"/>
           <p:nvPr/>
         </p:nvSpPr>
@@ -5234,7 +5264,7 @@
       </p:sp>
       <p:sp>
         <p:nvSpPr>
-          <p:cNvPr id="100117" name="Footer"/>
+          <p:cNvPr id="100118" name="Footer"/>
           <p:cNvSpPr txBox="1"/>
           <p:nvPr/>
         </p:nvSpPr>
@@ -5273,7 +5303,7 @@
       </p:sp>
       <p:sp>
         <p:nvSpPr>
-          <p:cNvPr id="100118" name="Col1"/>
+          <p:cNvPr id="100119" name="Col1"/>
           <p:cNvSpPr/>
           <p:nvPr/>
         </p:nvSpPr>
@@ -5302,7 +5332,7 @@
       </p:sp>
       <p:sp>
         <p:nvSpPr>
-          <p:cNvPr id="100119" name="ColBand1"/>
+          <p:cNvPr id="100120" name="ColBand1"/>
           <p:cNvSpPr/>
           <p:nvPr/>
         </p:nvSpPr>
@@ -5329,7 +5359,7 @@
       </p:sp>
       <p:sp>
         <p:nvSpPr>
-          <p:cNvPr id="100120" name="ColLab1"/>
+          <p:cNvPr id="100121" name="ColLab1"/>
           <p:cNvSpPr txBox="1"/>
           <p:nvPr/>
         </p:nvSpPr>
@@ -5368,7 +5398,7 @@
       </p:sp>
       <p:sp>
         <p:nvSpPr>
-          <p:cNvPr id="100121" name="ColBody1"/>
+          <p:cNvPr id="100122" name="ColBody1"/>
           <p:cNvSpPr txBox="1"/>
           <p:nvPr/>
         </p:nvSpPr>
@@ -5492,7 +5522,7 @@
       </p:sp>
       <p:sp>
         <p:nvSpPr>
-          <p:cNvPr id="100122" name="Col2"/>
+          <p:cNvPr id="100123" name="Col2"/>
           <p:cNvSpPr/>
           <p:nvPr/>
         </p:nvSpPr>
@@ -5521,7 +5551,7 @@
       </p:sp>
       <p:sp>
         <p:nvSpPr>
-          <p:cNvPr id="100123" name="ColBand2"/>
+          <p:cNvPr id="100124" name="ColBand2"/>
           <p:cNvSpPr/>
           <p:nvPr/>
         </p:nvSpPr>
@@ -5548,7 +5578,7 @@
       </p:sp>
       <p:sp>
         <p:nvSpPr>
-          <p:cNvPr id="100124" name="ColLab2"/>
+          <p:cNvPr id="100125" name="ColLab2"/>
           <p:cNvSpPr txBox="1"/>
           <p:nvPr/>
         </p:nvSpPr>
@@ -5587,7 +5617,7 @@
       </p:sp>
       <p:sp>
         <p:nvSpPr>
-          <p:cNvPr id="100125" name="ColBody2"/>
+          <p:cNvPr id="100126" name="ColBody2"/>
           <p:cNvSpPr txBox="1"/>
           <p:nvPr/>
         </p:nvSpPr>
@@ -5686,7 +5716,7 @@
       </p:sp>
       <p:sp>
         <p:nvSpPr>
-          <p:cNvPr id="100126" name="Col3"/>
+          <p:cNvPr id="100127" name="Col3"/>
           <p:cNvSpPr/>
           <p:nvPr/>
         </p:nvSpPr>
@@ -5715,7 +5745,7 @@
       </p:sp>
       <p:sp>
         <p:nvSpPr>
-          <p:cNvPr id="100127" name="ColBand3"/>
+          <p:cNvPr id="100128" name="ColBand3"/>
           <p:cNvSpPr/>
           <p:nvPr/>
         </p:nvSpPr>
@@ -5742,7 +5772,7 @@
       </p:sp>
       <p:sp>
         <p:nvSpPr>
-          <p:cNvPr id="100128" name="ColLab3"/>
+          <p:cNvPr id="100129" name="ColLab3"/>
           <p:cNvSpPr txBox="1"/>
           <p:nvPr/>
         </p:nvSpPr>
@@ -5781,7 +5811,7 @@
       </p:sp>
       <p:sp>
         <p:nvSpPr>
-          <p:cNvPr id="100129" name="ColBody3"/>
+          <p:cNvPr id="100130" name="ColBody3"/>
           <p:cNvSpPr txBox="1"/>
           <p:nvPr/>
         </p:nvSpPr>

</xml_diff>

<commit_message>
docs: retake the deck's G3 screenshot from the final code (grouped 1,005) and rebuild the deck
G3 asked from its starter chip in a session signed in through the access
screen, 1440x900 light theme; the chat table now shows 1,005, matching the
Evidence panel. G1 screenshots unchanged (no ungrouped counts).

Co-Authored-By: Claude Opus 5.5 <noreply@anthropic.com>
</commit_message>
<xml_diff>
--- a/docs/deck.pptx
+++ b/docs/deck.pptx
@@ -5,14 +5,14 @@
     <p:sldMasterId xmlns:r="http://schemas.openxmlformats.org/officeDocument/2006/relationships" id="2147483648" r:id="rId1"/>
   </p:sldMasterIdLst>
   <p:notesMasterIdLst>
-    <p:notesMasterId r:id="R59c87c463d4143f0"/>
+    <p:notesMasterId r:id="Rfe7e7fb364e54318"/>
   </p:notesMasterIdLst>
   <p:sldIdLst>
-    <p:sldId id="256" r:id="R769172414a734919"/>
-    <p:sldId id="257" r:id="R30ef1c6438884a91"/>
-    <p:sldId id="258" r:id="Rdf9b474b4cdf4e66"/>
-    <p:sldId id="259" r:id="R6bdaac1b3dd64025"/>
-    <p:sldId id="260" r:id="Rf399fd65d57f4aa3"/>
+    <p:sldId id="256" r:id="Rd7701c6e1de74b7f"/>
+    <p:sldId id="257" r:id="Rfffe1dbe52ea4be4"/>
+    <p:sldId id="258" r:id="R1b8cb8df6fa84371"/>
+    <p:sldId id="259" r:id="R34f16746d9e0423e"/>
+    <p:sldId id="260" r:id="R9c6a4f5df303465e"/>
   </p:sldIdLst>
   <p:sldSz cx="12192000" cy="6858000"/>
   <p:notesSz cx="6858000" cy="9144000"/>
@@ -640,7 +640,7 @@
           <a:p xmlns:a="http://schemas.openxmlformats.org/drawingml/2006/main">
             <a:r>
               <a:rPr lang="en-US"/>
-              <a:t>Both screenshots are the running app at 1440 by 900 in light theme, reopening saved conversations from the Recent chats rail. Left, exam question G3: 2.7% of Anchorage's scheduled passenger departures are Long-haul Flights, with the passenger-weighted 6.2% and cargo-inclusive 29.5% variants and the 3,000-mile definition stated; the Mission panel shows the route_mix call and its donuts and table, Data Confidence High. Right, exam question G1: New England ranked by Investment Opportunity Score, BOS 73.1, BGR 72.4 and BTV 71.9 leading 16 ranked airports; the Mission panel shows the rank_airports call, the Pillar bars and the score table, Data Confidence Medium because HVN and PSM are Provisional.</a:t>
+              <a:t>Both screenshots are the running app at 1440 by 900 in light theme: G3 as its answer finished, and G1 reopened from the Recent chats rail. Left, exam question G3: 2.7% of Anchorage's scheduled passenger departures are Long-haul Flights, with the passenger-weighted 6.2% and cargo-inclusive 29.5% variants and the 3,000-mile definition stated; the Mission panel shows the route_mix call and its donuts and table, Data Confidence High. Right, exam question G1: New England ranked by Investment Opportunity Score, BOS 73.1, BGR 72.4 and BTV 71.9 leading 16 ranked airports; the Mission panel shows the rank_airports call, the Pillar bars and the score table, Data Confidence Medium because HVN and PSM are Provisional.</a:t>
             </a:r>
           </a:p>
         </p:txBody>
@@ -4311,7 +4311,7 @@
           <p:nvPr/>
         </p:nvPicPr>
         <p:blipFill>
-          <a:blip xmlns:r="http://schemas.openxmlformats.org/officeDocument/2006/relationships" xmlns:a="http://schemas.openxmlformats.org/drawingml/2006/main" r:embed="R7d6df98475a44205"/>
+          <a:blip xmlns:r="http://schemas.openxmlformats.org/officeDocument/2006/relationships" xmlns:a="http://schemas.openxmlformats.org/drawingml/2006/main" r:embed="R2168f364d32b453f"/>
           <a:stretch xmlns:a="http://schemas.openxmlformats.org/drawingml/2006/main">
             <a:fillRect/>
           </a:stretch>
@@ -4896,7 +4896,7 @@
           <p:nvPr/>
         </p:nvPicPr>
         <p:blipFill>
-          <a:blip xmlns:r="http://schemas.openxmlformats.org/officeDocument/2006/relationships" xmlns:a="http://schemas.openxmlformats.org/drawingml/2006/main" r:embed="R84c46bf5a4824fda"/>
+          <a:blip xmlns:r="http://schemas.openxmlformats.org/officeDocument/2006/relationships" xmlns:a="http://schemas.openxmlformats.org/drawingml/2006/main" r:embed="R858f13acfc6041e7"/>
           <a:stretch xmlns:a="http://schemas.openxmlformats.org/drawingml/2006/main">
             <a:fillRect/>
           </a:stretch>
@@ -5027,7 +5027,7 @@
           <p:nvPr/>
         </p:nvPicPr>
         <p:blipFill>
-          <a:blip xmlns:r="http://schemas.openxmlformats.org/officeDocument/2006/relationships" xmlns:a="http://schemas.openxmlformats.org/drawingml/2006/main" r:embed="Re59852e05e7f4120"/>
+          <a:blip xmlns:r="http://schemas.openxmlformats.org/officeDocument/2006/relationships" xmlns:a="http://schemas.openxmlformats.org/drawingml/2006/main" r:embed="R82575409a7d14ff3"/>
           <a:stretch xmlns:a="http://schemas.openxmlformats.org/drawingml/2006/main">
             <a:fillRect/>
           </a:stretch>

</xml_diff>

<commit_message>
docs: retake the deck's G3 screenshot from 0fe5c11 so the table reads "(c) Cargo-inclusive"
The previous shot was taken at bbadf2f, before the ligature fix, and showed
"© Cargo-inclusive". The app was rebuilt with docker compose up --build, G3
was asked once from its starter chip in a session signed in through the access
screen ($0.056), and the saved answer was reopened in a second signed-in
session for the screenshot (no model call), at 1440x900 light theme. The chat
table shows 1,005 grouped, matching the Evidence panel and docs/examples.md.
G1 screenshots unchanged (no ungrouped counts). Deck rebuilt and all 5 slides
rendered and checked.

Co-Authored-By: Claude Opus 5.5 <noreply@anthropic.com>
</commit_message>
<xml_diff>
--- a/docs/deck.pptx
+++ b/docs/deck.pptx
@@ -5,14 +5,14 @@
     <p:sldMasterId xmlns:r="http://schemas.openxmlformats.org/officeDocument/2006/relationships" id="2147483648" r:id="rId1"/>
   </p:sldMasterIdLst>
   <p:notesMasterIdLst>
-    <p:notesMasterId r:id="Rfe7e7fb364e54318"/>
+    <p:notesMasterId r:id="Rf0e5163226b94fa3"/>
   </p:notesMasterIdLst>
   <p:sldIdLst>
-    <p:sldId id="256" r:id="Rd7701c6e1de74b7f"/>
-    <p:sldId id="257" r:id="Rfffe1dbe52ea4be4"/>
-    <p:sldId id="258" r:id="R1b8cb8df6fa84371"/>
-    <p:sldId id="259" r:id="R34f16746d9e0423e"/>
-    <p:sldId id="260" r:id="R9c6a4f5df303465e"/>
+    <p:sldId id="256" r:id="Rf32a74b1fddc4366"/>
+    <p:sldId id="257" r:id="R62bb10bb5d44483f"/>
+    <p:sldId id="258" r:id="Ra950cd5dad994503"/>
+    <p:sldId id="259" r:id="Redef0ee434b14e77"/>
+    <p:sldId id="260" r:id="R3b1f70e6815d44e7"/>
   </p:sldIdLst>
   <p:sldSz cx="12192000" cy="6858000"/>
   <p:notesSz cx="6858000" cy="9144000"/>
@@ -640,7 +640,7 @@
           <a:p xmlns:a="http://schemas.openxmlformats.org/drawingml/2006/main">
             <a:r>
               <a:rPr lang="en-US"/>
-              <a:t>Both screenshots are the running app at 1440 by 900 in light theme: G3 as its answer finished, and G1 reopened from the Recent chats rail. Left, exam question G3: 2.7% of Anchorage's scheduled passenger departures are Long-haul Flights, with the passenger-weighted 6.2% and cargo-inclusive 29.5% variants and the 3,000-mile definition stated; the Mission panel shows the route_mix call and its donuts and table, Data Confidence High. Right, exam question G1: New England ranked by Investment Opportunity Score, BOS 73.1, BGR 72.4 and BTV 71.9 leading 16 ranked airports; the Mission panel shows the rank_airports call, the Pillar bars and the score table, Data Confidence Medium because HVN and PSM are Provisional.</a:t>
+              <a:t>Both screenshots are the running app at 1440 by 900 in light theme: G3 asked from its starter chip and reopened from its saved conversation, and G1 reopened from the Recent chats rail. Left, exam question G3: 2.7% of Anchorage's scheduled passenger departures are Long-haul Flights, with the passenger-weighted 6.2% and cargo-inclusive 29.5% variants and the 3,000-mile definition stated; the Mission panel shows the route_mix call and its donuts and table, Data Confidence High. Right, exam question G1: New England ranked by Investment Opportunity Score, BOS 73.1, BGR 72.4 and BTV 71.9 leading 16 ranked airports; the Mission panel shows the rank_airports call, the Pillar bars and the score table, Data Confidence Medium because HVN and PSM are Provisional.</a:t>
             </a:r>
           </a:p>
         </p:txBody>
@@ -4311,7 +4311,7 @@
           <p:nvPr/>
         </p:nvPicPr>
         <p:blipFill>
-          <a:blip xmlns:r="http://schemas.openxmlformats.org/officeDocument/2006/relationships" xmlns:a="http://schemas.openxmlformats.org/drawingml/2006/main" r:embed="R2168f364d32b453f"/>
+          <a:blip xmlns:r="http://schemas.openxmlformats.org/officeDocument/2006/relationships" xmlns:a="http://schemas.openxmlformats.org/drawingml/2006/main" r:embed="R62cf89d4949f448d"/>
           <a:stretch xmlns:a="http://schemas.openxmlformats.org/drawingml/2006/main">
             <a:fillRect/>
           </a:stretch>
@@ -4896,7 +4896,7 @@
           <p:nvPr/>
         </p:nvPicPr>
         <p:blipFill>
-          <a:blip xmlns:r="http://schemas.openxmlformats.org/officeDocument/2006/relationships" xmlns:a="http://schemas.openxmlformats.org/drawingml/2006/main" r:embed="R858f13acfc6041e7"/>
+          <a:blip xmlns:r="http://schemas.openxmlformats.org/officeDocument/2006/relationships" xmlns:a="http://schemas.openxmlformats.org/drawingml/2006/main" r:embed="Rcd22b6b09f304cf9"/>
           <a:stretch xmlns:a="http://schemas.openxmlformats.org/drawingml/2006/main">
             <a:fillRect/>
           </a:stretch>
@@ -5027,7 +5027,7 @@
           <p:nvPr/>
         </p:nvPicPr>
         <p:blipFill>
-          <a:blip xmlns:r="http://schemas.openxmlformats.org/officeDocument/2006/relationships" xmlns:a="http://schemas.openxmlformats.org/drawingml/2006/main" r:embed="R82575409a7d14ff3"/>
+          <a:blip xmlns:r="http://schemas.openxmlformats.org/officeDocument/2006/relationships" xmlns:a="http://schemas.openxmlformats.org/drawingml/2006/main" r:embed="R4f960e65d7b14c3f"/>
           <a:stretch xmlns:a="http://schemas.openxmlformats.org/drawingml/2006/main">
             <a:fillRect/>
           </a:stretch>

</xml_diff>

<commit_message>
docs: refresh the deck for the live demo; screenshots retaken on Render
Slides 1 and 4 now carry the live demo URL (access code on request) as a
real hyperlink in the deck's ink colour. The three screenshots come from
https://airport-investment-agent-n37j.onrender.com at 1440x900, light
theme: G3 and G1 each asked once from their starter chip after signing in
through the access screen, shot after the follow-up chips appeared. The
PNGs are 256-colour, about 400 KB in total. The build_deck.py docstring
and the HANDOFF deck note describe the new provenance.

Co-Authored-By: Claude Opus 5.5 <noreply@anthropic.com>
</commit_message>
<xml_diff>
--- a/docs/deck.pptx
+++ b/docs/deck.pptx
@@ -5,14 +5,14 @@
     <p:sldMasterId xmlns:r="http://schemas.openxmlformats.org/officeDocument/2006/relationships" id="2147483648" r:id="rId1"/>
   </p:sldMasterIdLst>
   <p:notesMasterIdLst>
-    <p:notesMasterId r:id="Rf0e5163226b94fa3"/>
+    <p:notesMasterId r:id="R221887f790b94617"/>
   </p:notesMasterIdLst>
   <p:sldIdLst>
-    <p:sldId id="256" r:id="Rf32a74b1fddc4366"/>
-    <p:sldId id="257" r:id="R62bb10bb5d44483f"/>
-    <p:sldId id="258" r:id="Ra950cd5dad994503"/>
-    <p:sldId id="259" r:id="Redef0ee434b14e77"/>
-    <p:sldId id="260" r:id="R3b1f70e6815d44e7"/>
+    <p:sldId id="256" r:id="R3fb088fe38c14260"/>
+    <p:sldId id="257" r:id="Re59fb7b316f0415c"/>
+    <p:sldId id="258" r:id="R63b556d6f8164805"/>
+    <p:sldId id="259" r:id="R0318ca71d2484bc2"/>
+    <p:sldId id="260" r:id="R367d196017ff44eb"/>
   </p:sldIdLst>
   <p:sldSz cx="12192000" cy="6858000"/>
   <p:notesSz cx="6858000" cy="9144000"/>
@@ -359,10 +359,10 @@
         <a:srgbClr val="70AD47"/>
       </a:accent6>
       <a:hlink>
-        <a:srgbClr val="0563C1"/>
+        <a:srgbClr val="1B1A17"/>
       </a:hlink>
       <a:folHlink>
-        <a:srgbClr val="954F72"/>
+        <a:srgbClr val="1B1A17"/>
       </a:folHlink>
     </a:clrScheme>
     <a:fontScheme name="Office">
@@ -475,7 +475,7 @@
           <a:p xmlns:a="http://schemas.openxmlformats.org/drawingml/2006/main">
             <a:r>
               <a:rPr lang="en-US"/>
-              <a:t>An investor wants to know which US airports are the best candidates for terminal modernisation. No public dataset measures renovation profitability, so the agent works from an explicit Investment Thesis. Its three clauses become the three Pillars of the Investment Opportunity Score: Demand Momentum, Capacity Pressure and Market Scale, with default weights 0.35, 0.40 and 0.25. The score is a screening signal: it shortlists airports for a closer look and does not prove a renovation would pay off.</a:t>
+              <a:t>An investor wants to know which US airports are the best candidates for terminal modernisation. No public dataset measures renovation profitability, so the agent works from an explicit Investment Thesis. Its three clauses become the three Pillars of the Investment Opportunity Score: Demand Momentum, Capacity Pressure and Market Scale, with default weights 0.35, 0.40 and 0.25. The score is a screening signal: it shortlists airports for a closer look and does not prove a renovation would pay off. The agent is live on Render at the URL on the slide; the access code is sent on request.</a:t>
             </a:r>
           </a:p>
         </p:txBody>
@@ -585,7 +585,7 @@
           <a:p xmlns:a="http://schemas.openxmlformats.org/drawingml/2006/main">
             <a:r>
               <a:rPr lang="en-US"/>
-              <a:t>Each of seven metrics becomes a Percentile Score across the 402 Primary Airports, so a small airport compares with a large hub and outliers cannot stretch the scale. Pillars are weighted means of their metric percentiles. The Investment Opportunity Score is a weighted geometric mean of the Pillars, because the thesis is a conjunction: Martha's Vineyard has Demand Momentum 82.1 but Market Scale 28.4 and scores 54.7. A missing metric is imputed at the median and the score is labelled Provisional with the imputed metrics named. Data Confidence is computed from Coverage and recency, never judged by the model. On the right is the rank_airports Evidence card from the running app answering exam question G1 (New England): BOS has Pillars 50.2, 86.1 and 95.3 and scores 73.1.</a:t>
+              <a:t>Each of seven metrics becomes a Percentile Score across the 402 Primary Airports, so a small airport compares with a large hub and outliers cannot stretch the scale. Pillars are weighted means of their metric percentiles. The Investment Opportunity Score is a weighted geometric mean of the Pillars, because the thesis is a conjunction: Martha's Vineyard has Demand Momentum 82.1 but Market Scale 28.4 and scores 54.7. A missing metric is imputed at the median and the score is labelled Provisional with the imputed metrics named. Data Confidence is computed from Coverage and recency, never judged by the model. On the right is the rank_airports Evidence card from the live app answering exam question G1 (New England): BOS has Pillars 50.2, 86.1 and 95.3 and scores 73.1.</a:t>
             </a:r>
           </a:p>
         </p:txBody>
@@ -640,7 +640,7 @@
           <a:p xmlns:a="http://schemas.openxmlformats.org/drawingml/2006/main">
             <a:r>
               <a:rPr lang="en-US"/>
-              <a:t>Both screenshots are the running app at 1440 by 900 in light theme: G3 asked from its starter chip and reopened from its saved conversation, and G1 reopened from the Recent chats rail. Left, exam question G3: 2.7% of Anchorage's scheduled passenger departures are Long-haul Flights, with the passenger-weighted 6.2% and cargo-inclusive 29.5% variants and the 3,000-mile definition stated; the Mission panel shows the route_mix call and its donuts and table, Data Confidence High. Right, exam question G1: New England ranked by Investment Opportunity Score, BOS 73.1, BGR 72.4 and BTV 71.9 leading 16 ranked airports; the Mission panel shows the rank_airports call, the Pillar bars and the score table, Data Confidence Medium because HVN and PSM are Provisional.</a:t>
+              <a:t>Both screenshots are the live demo on Render at 1440 by 900 in light theme, each question asked once from its starter chip after signing in through the access screen. Left, exam question G3: 2.7% of Anchorage's scheduled passenger departures are Long-haul Flights, with the passenger-weighted 6.2% and cargo-inclusive 29.5% variants and the 3,000-mile definition stated; the Mission panel shows the route_mix call and its donuts and table, Data Confidence High. Right, exam question G1: New England ranked by Investment Opportunity Score, BOS 73.1, BGR 72.4 and BTV 71.9 leading 16 ranked airports; the Mission panel shows the rank_airports call, the Pillar bars and the score table, Data Confidence Medium because HVN and PSM are Provisional.</a:t>
             </a:r>
           </a:p>
         </p:txBody>
@@ -1935,7 +1935,7 @@
         </p:nvSpPr>
         <p:spPr>
           <a:xfrm xmlns:a="http://schemas.openxmlformats.org/drawingml/2006/main">
-            <a:off x="540000" y="5544000"/>
+            <a:off x="540000" y="5472000"/>
             <a:ext cx="11112120" cy="504000"/>
           </a:xfrm>
           <a:prstGeom xmlns:a="http://schemas.openxmlformats.org/drawingml/2006/main" prst="rect">
@@ -1962,7 +1962,7 @@
         </p:nvSpPr>
         <p:spPr>
           <a:xfrm xmlns:a="http://schemas.openxmlformats.org/drawingml/2006/main">
-            <a:off x="792000" y="5544000"/>
+            <a:off x="792000" y="5472000"/>
             <a:ext cx="10608120" cy="504000"/>
           </a:xfrm>
           <a:prstGeom xmlns:a="http://schemas.openxmlformats.org/drawingml/2006/main" prst="rect">
@@ -1989,6 +1989,126 @@
                 <a:ea typeface="Arial"/>
               </a:rPr>
               <a:t>The score screens candidates. It does not prove that a renovation would be profitable.</a:t>
+            </a:r>
+          </a:p>
+        </p:txBody>
+      </p:sp>
+      <p:sp>
+        <p:nvSpPr>
+          <p:cNvPr id="100028" name="LiveLabel"/>
+          <p:cNvSpPr txBox="1"/>
+          <p:nvPr/>
+        </p:nvSpPr>
+        <p:spPr>
+          <a:xfrm xmlns:a="http://schemas.openxmlformats.org/drawingml/2006/main">
+            <a:off x="540000" y="6120000"/>
+            <a:ext cx="1044000" cy="216000"/>
+          </a:xfrm>
+          <a:prstGeom xmlns:a="http://schemas.openxmlformats.org/drawingml/2006/main" prst="rect">
+            <a:avLst/>
+          </a:prstGeom>
+          <a:noFill xmlns:a="http://schemas.openxmlformats.org/drawingml/2006/main"/>
+          <a:ln xmlns:a="http://schemas.openxmlformats.org/drawingml/2006/main">
+            <a:noFill/>
+          </a:ln>
+        </p:spPr>
+        <p:txBody>
+          <a:bodyPr xmlns:a="http://schemas.openxmlformats.org/drawingml/2006/main" lIns="0" tIns="0" rIns="0" bIns="0" anchor="ctr">
+            <a:noAutofit/>
+          </a:bodyPr>
+          <a:lstStyle xmlns:a="http://schemas.openxmlformats.org/drawingml/2006/main"/>
+          <a:p xmlns:a="http://schemas.openxmlformats.org/drawingml/2006/main">
+            <a:pPr algn="l"/>
+            <a:r>
+              <a:rPr lang="en-US" sz="1100" b="0">
+                <a:solidFill>
+                  <a:srgbClr val="66645E"/>
+                </a:solidFill>
+                <a:latin typeface="Consolas"/>
+                <a:ea typeface="Consolas"/>
+              </a:rPr>
+              <a:t>LIVE DEMO</a:t>
+            </a:r>
+          </a:p>
+        </p:txBody>
+      </p:sp>
+      <p:sp>
+        <p:nvSpPr>
+          <p:cNvPr id="100029" name="LiveUrl">
+            <a:hlinkClick xmlns:r="http://schemas.openxmlformats.org/officeDocument/2006/relationships" xmlns:a="http://schemas.openxmlformats.org/drawingml/2006/main" r:id="Re5ecb4acb1e8451d"/>
+          </p:cNvPr>
+          <p:cNvSpPr txBox="1"/>
+          <p:nvPr/>
+        </p:nvSpPr>
+        <p:spPr>
+          <a:xfrm xmlns:a="http://schemas.openxmlformats.org/drawingml/2006/main">
+            <a:off x="1584000" y="6120000"/>
+            <a:ext cx="4824000" cy="216000"/>
+          </a:xfrm>
+          <a:prstGeom xmlns:a="http://schemas.openxmlformats.org/drawingml/2006/main" prst="rect">
+            <a:avLst/>
+          </a:prstGeom>
+          <a:noFill xmlns:a="http://schemas.openxmlformats.org/drawingml/2006/main"/>
+          <a:ln xmlns:a="http://schemas.openxmlformats.org/drawingml/2006/main">
+            <a:noFill/>
+          </a:ln>
+        </p:spPr>
+        <p:txBody>
+          <a:bodyPr xmlns:a="http://schemas.openxmlformats.org/drawingml/2006/main" lIns="0" tIns="0" rIns="0" bIns="0" anchor="ctr">
+            <a:noAutofit/>
+          </a:bodyPr>
+          <a:lstStyle xmlns:a="http://schemas.openxmlformats.org/drawingml/2006/main"/>
+          <a:p xmlns:a="http://schemas.openxmlformats.org/drawingml/2006/main">
+            <a:pPr algn="l"/>
+            <a:r>
+              <a:rPr lang="en-US" sz="1300" b="1">
+                <a:solidFill>
+                  <a:srgbClr val="1B1A17"/>
+                </a:solidFill>
+                <a:latin typeface="Consolas"/>
+                <a:ea typeface="Consolas"/>
+                <a:hlinkClick xmlns:r="http://schemas.openxmlformats.org/officeDocument/2006/relationships" r:id="Re5ecb4acb1e8451d"/>
+              </a:rPr>
+              <a:t>https://airport-investment-agent-n37j.onrender.com</a:t>
+            </a:r>
+          </a:p>
+        </p:txBody>
+      </p:sp>
+      <p:sp>
+        <p:nvSpPr>
+          <p:cNvPr id="100030" name="LiveNote"/>
+          <p:cNvSpPr txBox="1"/>
+          <p:nvPr/>
+        </p:nvSpPr>
+        <p:spPr>
+          <a:xfrm xmlns:a="http://schemas.openxmlformats.org/drawingml/2006/main">
+            <a:off x="6264000" y="6120000"/>
+            <a:ext cx="5388120" cy="216000"/>
+          </a:xfrm>
+          <a:prstGeom xmlns:a="http://schemas.openxmlformats.org/drawingml/2006/main" prst="rect">
+            <a:avLst/>
+          </a:prstGeom>
+          <a:noFill xmlns:a="http://schemas.openxmlformats.org/drawingml/2006/main"/>
+          <a:ln xmlns:a="http://schemas.openxmlformats.org/drawingml/2006/main">
+            <a:noFill/>
+          </a:ln>
+        </p:spPr>
+        <p:txBody>
+          <a:bodyPr xmlns:a="http://schemas.openxmlformats.org/drawingml/2006/main" lIns="0" tIns="0" rIns="0" bIns="0" anchor="ctr">
+            <a:noAutofit/>
+          </a:bodyPr>
+          <a:lstStyle xmlns:a="http://schemas.openxmlformats.org/drawingml/2006/main"/>
+          <a:p xmlns:a="http://schemas.openxmlformats.org/drawingml/2006/main">
+            <a:pPr algn="l"/>
+            <a:r>
+              <a:rPr lang="en-US" sz="1300" b="0">
+                <a:solidFill>
+                  <a:srgbClr val="66645E"/>
+                </a:solidFill>
+                <a:latin typeface="Arial"/>
+                <a:ea typeface="Arial"/>
+              </a:rPr>
+              <a:t>Try it in a browser  ·  access code on request</a:t>
             </a:r>
           </a:p>
         </p:txBody>
@@ -2017,7 +2137,7 @@
       <p:grpSpPr/>
       <p:sp>
         <p:nvSpPr>
-          <p:cNvPr id="100028" name="Eyebrow"/>
+          <p:cNvPr id="100031" name="Eyebrow"/>
           <p:cNvSpPr txBox="1"/>
           <p:nvPr/>
         </p:nvSpPr>
@@ -2056,7 +2176,7 @@
       </p:sp>
       <p:sp>
         <p:nvSpPr>
-          <p:cNvPr id="100029" name="Motif1"/>
+          <p:cNvPr id="100032" name="Motif1"/>
           <p:cNvSpPr/>
           <p:nvPr/>
         </p:nvSpPr>
@@ -2083,7 +2203,7 @@
       </p:sp>
       <p:sp>
         <p:nvSpPr>
-          <p:cNvPr id="100030" name="Motif2"/>
+          <p:cNvPr id="100033" name="Motif2"/>
           <p:cNvSpPr/>
           <p:nvPr/>
         </p:nvSpPr>
@@ -2110,7 +2230,7 @@
       </p:sp>
       <p:sp>
         <p:nvSpPr>
-          <p:cNvPr id="100031" name="Motif3"/>
+          <p:cNvPr id="100034" name="Motif3"/>
           <p:cNvSpPr/>
           <p:nvPr/>
         </p:nvSpPr>
@@ -2137,7 +2257,7 @@
       </p:sp>
       <p:sp>
         <p:nvSpPr>
-          <p:cNvPr id="100032" name="Title"/>
+          <p:cNvPr id="100035" name="Title"/>
           <p:cNvSpPr txBox="1"/>
           <p:nvPr/>
         </p:nvSpPr>
@@ -2176,7 +2296,7 @@
       </p:sp>
       <p:sp>
         <p:nvSpPr>
-          <p:cNvPr id="100033" name="Footer"/>
+          <p:cNvPr id="100036" name="Footer"/>
           <p:cNvSpPr txBox="1"/>
           <p:nvPr/>
         </p:nvSpPr>
@@ -2215,7 +2335,7 @@
       </p:sp>
       <p:sp>
         <p:nvSpPr>
-          <p:cNvPr id="100034" name="Step1"/>
+          <p:cNvPr id="100037" name="Step1"/>
           <p:cNvSpPr/>
           <p:nvPr/>
         </p:nvSpPr>
@@ -2244,7 +2364,7 @@
       </p:sp>
       <p:sp>
         <p:nvSpPr>
-          <p:cNvPr id="100035" name="StepEb1"/>
+          <p:cNvPr id="100038" name="StepEb1"/>
           <p:cNvSpPr txBox="1"/>
           <p:nvPr/>
         </p:nvSpPr>
@@ -2283,7 +2403,7 @@
       </p:sp>
       <p:sp>
         <p:nvSpPr>
-          <p:cNvPr id="100036" name="StepHead1"/>
+          <p:cNvPr id="100039" name="StepHead1"/>
           <p:cNvSpPr txBox="1"/>
           <p:nvPr/>
         </p:nvSpPr>
@@ -2322,7 +2442,7 @@
       </p:sp>
       <p:sp>
         <p:nvSpPr>
-          <p:cNvPr id="100037" name="StepBody1"/>
+          <p:cNvPr id="100040" name="StepBody1"/>
           <p:cNvSpPr txBox="1"/>
           <p:nvPr/>
         </p:nvSpPr>
@@ -2361,7 +2481,7 @@
       </p:sp>
       <p:sp>
         <p:nvSpPr>
-          <p:cNvPr id="100038" name="Step2"/>
+          <p:cNvPr id="100041" name="Step2"/>
           <p:cNvSpPr/>
           <p:nvPr/>
         </p:nvSpPr>
@@ -2390,7 +2510,7 @@
       </p:sp>
       <p:sp>
         <p:nvSpPr>
-          <p:cNvPr id="100039" name="StepEb2"/>
+          <p:cNvPr id="100042" name="StepEb2"/>
           <p:cNvSpPr txBox="1"/>
           <p:nvPr/>
         </p:nvSpPr>
@@ -2429,7 +2549,7 @@
       </p:sp>
       <p:sp>
         <p:nvSpPr>
-          <p:cNvPr id="100040" name="StepHead2"/>
+          <p:cNvPr id="100043" name="StepHead2"/>
           <p:cNvSpPr txBox="1"/>
           <p:nvPr/>
         </p:nvSpPr>
@@ -2468,7 +2588,7 @@
       </p:sp>
       <p:sp>
         <p:nvSpPr>
-          <p:cNvPr id="100041" name="StepBody2"/>
+          <p:cNvPr id="100044" name="StepBody2"/>
           <p:cNvSpPr txBox="1"/>
           <p:nvPr/>
         </p:nvSpPr>
@@ -2596,7 +2716,7 @@
       </p:sp>
       <p:sp>
         <p:nvSpPr>
-          <p:cNvPr id="100042" name="Step3"/>
+          <p:cNvPr id="100045" name="Step3"/>
           <p:cNvSpPr/>
           <p:nvPr/>
         </p:nvSpPr>
@@ -2623,7 +2743,7 @@
       </p:sp>
       <p:sp>
         <p:nvSpPr>
-          <p:cNvPr id="100043" name="StepEb3"/>
+          <p:cNvPr id="100046" name="StepEb3"/>
           <p:cNvSpPr txBox="1"/>
           <p:nvPr/>
         </p:nvSpPr>
@@ -2662,7 +2782,7 @@
       </p:sp>
       <p:sp>
         <p:nvSpPr>
-          <p:cNvPr id="100044" name="StepHead3"/>
+          <p:cNvPr id="100047" name="StepHead3"/>
           <p:cNvSpPr txBox="1"/>
           <p:nvPr/>
         </p:nvSpPr>
@@ -2701,7 +2821,7 @@
       </p:sp>
       <p:sp>
         <p:nvSpPr>
-          <p:cNvPr id="100045" name="StepBody3"/>
+          <p:cNvPr id="100048" name="StepBody3"/>
           <p:cNvSpPr txBox="1"/>
           <p:nvPr/>
         </p:nvSpPr>
@@ -2740,7 +2860,7 @@
       </p:sp>
       <p:sp>
         <p:nvSpPr>
-          <p:cNvPr id="100046" name="Step4"/>
+          <p:cNvPr id="100049" name="Step4"/>
           <p:cNvSpPr/>
           <p:nvPr/>
         </p:nvSpPr>
@@ -2769,7 +2889,7 @@
       </p:sp>
       <p:sp>
         <p:nvSpPr>
-          <p:cNvPr id="100047" name="StepEb4"/>
+          <p:cNvPr id="100050" name="StepEb4"/>
           <p:cNvSpPr txBox="1"/>
           <p:nvPr/>
         </p:nvSpPr>
@@ -2808,7 +2928,7 @@
       </p:sp>
       <p:sp>
         <p:nvSpPr>
-          <p:cNvPr id="100048" name="StepHead4"/>
+          <p:cNvPr id="100051" name="StepHead4"/>
           <p:cNvSpPr txBox="1"/>
           <p:nvPr/>
         </p:nvSpPr>
@@ -2847,7 +2967,7 @@
       </p:sp>
       <p:sp>
         <p:nvSpPr>
-          <p:cNvPr id="100049" name="StepBody4"/>
+          <p:cNvPr id="100052" name="StepBody4"/>
           <p:cNvSpPr txBox="1"/>
           <p:nvPr/>
         </p:nvSpPr>
@@ -2886,7 +3006,7 @@
       </p:sp>
       <p:cxnSp>
         <p:nvCxnSpPr>
-          <p:cNvPr id="100050" name="Connector 1"/>
+          <p:cNvPr id="100053" name="Connector 1"/>
           <p:cNvCxnSpPr/>
           <p:nvPr/>
         </p:nvCxnSpPr>
@@ -2908,7 +3028,7 @@
       </p:cxnSp>
       <p:cxnSp>
         <p:nvCxnSpPr>
-          <p:cNvPr id="100051" name="Connector 2"/>
+          <p:cNvPr id="100054" name="Connector 2"/>
           <p:cNvCxnSpPr/>
           <p:nvPr/>
         </p:nvCxnSpPr>
@@ -2930,7 +3050,7 @@
       </p:cxnSp>
       <p:cxnSp>
         <p:nvCxnSpPr>
-          <p:cNvPr id="100052" name="Connector 3"/>
+          <p:cNvPr id="100055" name="Connector 3"/>
           <p:cNvCxnSpPr/>
           <p:nvPr/>
         </p:nvCxnSpPr>
@@ -2952,7 +3072,7 @@
       </p:cxnSp>
       <p:sp>
         <p:nvSpPr>
-          <p:cNvPr id="100053" name="EnvLabel"/>
+          <p:cNvPr id="100056" name="EnvLabel"/>
           <p:cNvSpPr txBox="1"/>
           <p:nvPr/>
         </p:nvSpPr>
@@ -2991,7 +3111,7 @@
       </p:sp>
       <p:sp>
         <p:nvSpPr>
-          <p:cNvPr id="100054" name="Chip1"/>
+          <p:cNvPr id="100057" name="Chip1"/>
           <p:cNvSpPr/>
           <p:nvPr/>
         </p:nvSpPr>
@@ -3020,7 +3140,7 @@
       </p:sp>
       <p:sp>
         <p:nvSpPr>
-          <p:cNvPr id="100055" name="ChipText1"/>
+          <p:cNvPr id="100058" name="ChipText1"/>
           <p:cNvSpPr txBox="1"/>
           <p:nvPr/>
         </p:nvSpPr>
@@ -3059,7 +3179,7 @@
       </p:sp>
       <p:sp>
         <p:nvSpPr>
-          <p:cNvPr id="100056" name="Chip2"/>
+          <p:cNvPr id="100059" name="Chip2"/>
           <p:cNvSpPr/>
           <p:nvPr/>
         </p:nvSpPr>
@@ -3088,7 +3208,7 @@
       </p:sp>
       <p:sp>
         <p:nvSpPr>
-          <p:cNvPr id="100057" name="ChipText2"/>
+          <p:cNvPr id="100060" name="ChipText2"/>
           <p:cNvSpPr txBox="1"/>
           <p:nvPr/>
         </p:nvSpPr>
@@ -3127,7 +3247,7 @@
       </p:sp>
       <p:sp>
         <p:nvSpPr>
-          <p:cNvPr id="100058" name="Chip3"/>
+          <p:cNvPr id="100061" name="Chip3"/>
           <p:cNvSpPr/>
           <p:nvPr/>
         </p:nvSpPr>
@@ -3156,7 +3276,7 @@
       </p:sp>
       <p:sp>
         <p:nvSpPr>
-          <p:cNvPr id="100059" name="ChipText3"/>
+          <p:cNvPr id="100062" name="ChipText3"/>
           <p:cNvSpPr txBox="1"/>
           <p:nvPr/>
         </p:nvSpPr>
@@ -3195,7 +3315,7 @@
       </p:sp>
       <p:sp>
         <p:nvSpPr>
-          <p:cNvPr id="100060" name="Chip4"/>
+          <p:cNvPr id="100063" name="Chip4"/>
           <p:cNvSpPr/>
           <p:nvPr/>
         </p:nvSpPr>
@@ -3224,7 +3344,7 @@
       </p:sp>
       <p:sp>
         <p:nvSpPr>
-          <p:cNvPr id="100061" name="ChipText4"/>
+          <p:cNvPr id="100064" name="ChipText4"/>
           <p:cNvSpPr txBox="1"/>
           <p:nvPr/>
         </p:nvSpPr>
@@ -3263,7 +3383,7 @@
       </p:sp>
       <p:sp>
         <p:nvSpPr>
-          <p:cNvPr id="100062" name="Chip5"/>
+          <p:cNvPr id="100065" name="Chip5"/>
           <p:cNvSpPr/>
           <p:nvPr/>
         </p:nvSpPr>
@@ -3292,7 +3412,7 @@
       </p:sp>
       <p:sp>
         <p:nvSpPr>
-          <p:cNvPr id="100063" name="ChipText5"/>
+          <p:cNvPr id="100066" name="ChipText5"/>
           <p:cNvSpPr txBox="1"/>
           <p:nvPr/>
         </p:nvSpPr>
@@ -3331,7 +3451,7 @@
       </p:sp>
       <p:sp>
         <p:nvSpPr>
-          <p:cNvPr id="100064" name="Chip6"/>
+          <p:cNvPr id="100067" name="Chip6"/>
           <p:cNvSpPr/>
           <p:nvPr/>
         </p:nvSpPr>
@@ -3360,7 +3480,7 @@
       </p:sp>
       <p:sp>
         <p:nvSpPr>
-          <p:cNvPr id="100065" name="ChipText6"/>
+          <p:cNvPr id="100068" name="ChipText6"/>
           <p:cNvSpPr txBox="1"/>
           <p:nvPr/>
         </p:nvSpPr>
@@ -3399,7 +3519,7 @@
       </p:sp>
       <p:sp>
         <p:nvSpPr>
-          <p:cNvPr id="100066" name="Grounding"/>
+          <p:cNvPr id="100069" name="Grounding"/>
           <p:cNvSpPr txBox="1"/>
           <p:nvPr/>
         </p:nvSpPr>
@@ -3460,7 +3580,7 @@
       <p:grpSpPr/>
       <p:sp>
         <p:nvSpPr>
-          <p:cNvPr id="100067" name="Eyebrow"/>
+          <p:cNvPr id="100070" name="Eyebrow"/>
           <p:cNvSpPr txBox="1"/>
           <p:nvPr/>
         </p:nvSpPr>
@@ -3499,7 +3619,7 @@
       </p:sp>
       <p:sp>
         <p:nvSpPr>
-          <p:cNvPr id="100068" name="Motif1"/>
+          <p:cNvPr id="100071" name="Motif1"/>
           <p:cNvSpPr/>
           <p:nvPr/>
         </p:nvSpPr>
@@ -3526,7 +3646,7 @@
       </p:sp>
       <p:sp>
         <p:nvSpPr>
-          <p:cNvPr id="100069" name="Motif2"/>
+          <p:cNvPr id="100072" name="Motif2"/>
           <p:cNvSpPr/>
           <p:nvPr/>
         </p:nvSpPr>
@@ -3553,7 +3673,7 @@
       </p:sp>
       <p:sp>
         <p:nvSpPr>
-          <p:cNvPr id="100070" name="Motif3"/>
+          <p:cNvPr id="100073" name="Motif3"/>
           <p:cNvSpPr/>
           <p:nvPr/>
         </p:nvSpPr>
@@ -3580,7 +3700,7 @@
       </p:sp>
       <p:sp>
         <p:nvSpPr>
-          <p:cNvPr id="100071" name="Title"/>
+          <p:cNvPr id="100074" name="Title"/>
           <p:cNvSpPr txBox="1"/>
           <p:nvPr/>
         </p:nvSpPr>
@@ -3619,7 +3739,7 @@
       </p:sp>
       <p:sp>
         <p:nvSpPr>
-          <p:cNvPr id="100072" name="Footer"/>
+          <p:cNvPr id="100075" name="Footer"/>
           <p:cNvSpPr txBox="1"/>
           <p:nvPr/>
         </p:nvSpPr>
@@ -3658,7 +3778,7 @@
       </p:sp>
       <p:sp>
         <p:nvSpPr>
-          <p:cNvPr id="100073" name="PctLabel"/>
+          <p:cNvPr id="100076" name="PctLabel"/>
           <p:cNvSpPr txBox="1"/>
           <p:nvPr/>
         </p:nvSpPr>
@@ -3697,7 +3817,7 @@
       </p:sp>
       <p:sp>
         <p:nvSpPr>
-          <p:cNvPr id="100074" name="RowSw1"/>
+          <p:cNvPr id="100077" name="RowSw1"/>
           <p:cNvSpPr/>
           <p:nvPr/>
         </p:nvSpPr>
@@ -3724,7 +3844,7 @@
       </p:sp>
       <p:sp>
         <p:nvSpPr>
-          <p:cNvPr id="100075" name="RowName1"/>
+          <p:cNvPr id="100078" name="RowName1"/>
           <p:cNvSpPr txBox="1"/>
           <p:nvPr/>
         </p:nvSpPr>
@@ -3763,7 +3883,7 @@
       </p:sp>
       <p:sp>
         <p:nvSpPr>
-          <p:cNvPr id="100076" name="RowWt1"/>
+          <p:cNvPr id="100079" name="RowWt1"/>
           <p:cNvSpPr txBox="1"/>
           <p:nvPr/>
         </p:nvSpPr>
@@ -3802,7 +3922,7 @@
       </p:sp>
       <p:sp>
         <p:nvSpPr>
-          <p:cNvPr id="100077" name="RowMet1"/>
+          <p:cNvPr id="100080" name="RowMet1"/>
           <p:cNvSpPr txBox="1"/>
           <p:nvPr/>
         </p:nvSpPr>
@@ -3841,7 +3961,7 @@
       </p:sp>
       <p:sp>
         <p:nvSpPr>
-          <p:cNvPr id="100078" name="RowSw2"/>
+          <p:cNvPr id="100081" name="RowSw2"/>
           <p:cNvSpPr/>
           <p:nvPr/>
         </p:nvSpPr>
@@ -3868,7 +3988,7 @@
       </p:sp>
       <p:sp>
         <p:nvSpPr>
-          <p:cNvPr id="100079" name="RowName2"/>
+          <p:cNvPr id="100082" name="RowName2"/>
           <p:cNvSpPr txBox="1"/>
           <p:nvPr/>
         </p:nvSpPr>
@@ -3907,7 +4027,7 @@
       </p:sp>
       <p:sp>
         <p:nvSpPr>
-          <p:cNvPr id="100080" name="RowWt2"/>
+          <p:cNvPr id="100083" name="RowWt2"/>
           <p:cNvSpPr txBox="1"/>
           <p:nvPr/>
         </p:nvSpPr>
@@ -3946,7 +4066,7 @@
       </p:sp>
       <p:sp>
         <p:nvSpPr>
-          <p:cNvPr id="100081" name="RowMet2"/>
+          <p:cNvPr id="100084" name="RowMet2"/>
           <p:cNvSpPr txBox="1"/>
           <p:nvPr/>
         </p:nvSpPr>
@@ -3985,7 +4105,7 @@
       </p:sp>
       <p:sp>
         <p:nvSpPr>
-          <p:cNvPr id="100082" name="RowSw3"/>
+          <p:cNvPr id="100085" name="RowSw3"/>
           <p:cNvSpPr/>
           <p:nvPr/>
         </p:nvSpPr>
@@ -4012,7 +4132,7 @@
       </p:sp>
       <p:sp>
         <p:nvSpPr>
-          <p:cNvPr id="100083" name="RowName3"/>
+          <p:cNvPr id="100086" name="RowName3"/>
           <p:cNvSpPr txBox="1"/>
           <p:nvPr/>
         </p:nvSpPr>
@@ -4051,7 +4171,7 @@
       </p:sp>
       <p:sp>
         <p:nvSpPr>
-          <p:cNvPr id="100084" name="RowWt3"/>
+          <p:cNvPr id="100087" name="RowWt3"/>
           <p:cNvSpPr txBox="1"/>
           <p:nvPr/>
         </p:nvSpPr>
@@ -4090,7 +4210,7 @@
       </p:sp>
       <p:sp>
         <p:nvSpPr>
-          <p:cNvPr id="100085" name="RowMet3"/>
+          <p:cNvPr id="100088" name="RowMet3"/>
           <p:cNvSpPr txBox="1"/>
           <p:nvPr/>
         </p:nvSpPr>
@@ -4129,7 +4249,7 @@
       </p:sp>
       <p:sp>
         <p:nvSpPr>
-          <p:cNvPr id="100086" name="Formula"/>
+          <p:cNvPr id="100089" name="Formula"/>
           <p:cNvSpPr/>
           <p:nvPr/>
         </p:nvSpPr>
@@ -4158,7 +4278,7 @@
       </p:sp>
       <p:sp>
         <p:nvSpPr>
-          <p:cNvPr id="100087" name="FormulaLabel"/>
+          <p:cNvPr id="100090" name="FormulaLabel"/>
           <p:cNvSpPr txBox="1"/>
           <p:nvPr/>
         </p:nvSpPr>
@@ -4197,7 +4317,7 @@
       </p:sp>
       <p:sp>
         <p:nvSpPr>
-          <p:cNvPr id="100088" name="FormulaText"/>
+          <p:cNvPr id="100091" name="FormulaText"/>
           <p:cNvSpPr txBox="1"/>
           <p:nvPr/>
         </p:nvSpPr>
@@ -4236,7 +4356,7 @@
       </p:sp>
       <p:sp>
         <p:nvSpPr>
-          <p:cNvPr id="100089" name="FormulaNote"/>
+          <p:cNvPr id="100092" name="FormulaNote"/>
           <p:cNvSpPr txBox="1"/>
           <p:nvPr/>
         </p:nvSpPr>
@@ -4275,14 +4395,14 @@
       </p:sp>
       <p:sp>
         <p:nvSpPr>
-          <p:cNvPr id="100090" name="ShotFrame"/>
+          <p:cNvPr id="100093" name="ShotFrame"/>
           <p:cNvSpPr/>
           <p:nvPr/>
         </p:nvSpPr>
         <p:spPr>
           <a:xfrm xmlns:a="http://schemas.openxmlformats.org/drawingml/2006/main">
             <a:off x="9114120" y="1494000"/>
-            <a:ext cx="2556000" cy="4289760"/>
+            <a:ext cx="2556000" cy="4317840"/>
           </a:xfrm>
           <a:prstGeom xmlns:a="http://schemas.openxmlformats.org/drawingml/2006/main" prst="rect">
             <a:avLst/>
@@ -4304,14 +4424,14 @@
       </p:sp>
       <p:pic>
         <p:nvPicPr>
-          <p:cNvPr id="100091" name="Picture 1" descr="rank_airports Evidence card in the running app for New England: Pillar bars per airport against the median (50), and BOS first with score 73.1 and Pillars 50.2, 86.1, 95.3"/>
+          <p:cNvPr id="100094" name="Picture 1" descr="rank_airports Evidence card in the live app for New England: Pillar bars per airport against the median (50), and BOS first with score 73.1 and Pillars 50.2, 86.1, 95.3"/>
           <p:cNvPicPr>
             <a:picLocks xmlns:a="http://schemas.openxmlformats.org/drawingml/2006/main" noChangeAspect="1"/>
           </p:cNvPicPr>
           <p:nvPr/>
         </p:nvPicPr>
         <p:blipFill>
-          <a:blip xmlns:r="http://schemas.openxmlformats.org/officeDocument/2006/relationships" xmlns:a="http://schemas.openxmlformats.org/drawingml/2006/main" r:embed="R62cf89d4949f448d"/>
+          <a:blip xmlns:r="http://schemas.openxmlformats.org/officeDocument/2006/relationships" xmlns:a="http://schemas.openxmlformats.org/drawingml/2006/main" r:embed="R32b97ddeb7384ad7"/>
           <a:stretch xmlns:a="http://schemas.openxmlformats.org/drawingml/2006/main">
             <a:fillRect/>
           </a:stretch>
@@ -4319,7 +4439,7 @@
         <p:spPr>
           <a:xfrm xmlns:a="http://schemas.openxmlformats.org/drawingml/2006/main">
             <a:off x="9132120" y="1512000"/>
-            <a:ext cx="2520000" cy="4253760"/>
+            <a:ext cx="2520000" cy="4281840"/>
           </a:xfrm>
           <a:prstGeom xmlns:a="http://schemas.openxmlformats.org/drawingml/2006/main" prst="rect">
             <a:avLst/>
@@ -4328,13 +4448,13 @@
       </p:pic>
       <p:sp>
         <p:nvSpPr>
-          <p:cNvPr id="100092" name="ShotCap"/>
-          <p:cNvSpPr txBox="1"/>
-          <p:nvPr/>
-        </p:nvSpPr>
-        <p:spPr>
-          <a:xfrm xmlns:a="http://schemas.openxmlformats.org/drawingml/2006/main">
-            <a:off x="9132120" y="5837760"/>
+          <p:cNvPr id="100095" name="ShotCap"/>
+          <p:cNvSpPr txBox="1"/>
+          <p:nvPr/>
+        </p:nvSpPr>
+        <p:spPr>
+          <a:xfrm xmlns:a="http://schemas.openxmlformats.org/drawingml/2006/main">
+            <a:off x="9132120" y="5865840"/>
             <a:ext cx="2520000" cy="576000"/>
           </a:xfrm>
           <a:prstGeom xmlns:a="http://schemas.openxmlformats.org/drawingml/2006/main" prst="rect">
@@ -4360,14 +4480,14 @@
                 <a:latin typeface="Arial"/>
                 <a:ea typeface="Arial"/>
               </a:rPr>
-              <a:t>Running app, G1 Mission panel: BOS Pillars 50.2 / 86.1 / 95.3 give 73.1.</a:t>
-            </a:r>
-          </a:p>
-        </p:txBody>
-      </p:sp>
-      <p:sp>
-        <p:nvSpPr>
-          <p:cNvPr id="100093" name="FactLab1"/>
+              <a:t>Live app, G1 Mission panel: BOS Pillars 50.2 / 86.1 / 95.3 give 73.1.</a:t>
+            </a:r>
+          </a:p>
+        </p:txBody>
+      </p:sp>
+      <p:sp>
+        <p:nvSpPr>
+          <p:cNvPr id="100096" name="FactLab1"/>
           <p:cNvSpPr txBox="1"/>
           <p:nvPr/>
         </p:nvSpPr>
@@ -4406,7 +4526,7 @@
       </p:sp>
       <p:sp>
         <p:nvSpPr>
-          <p:cNvPr id="100094" name="FactBody1"/>
+          <p:cNvPr id="100097" name="FactBody1"/>
           <p:cNvSpPr txBox="1"/>
           <p:nvPr/>
         </p:nvSpPr>
@@ -4445,7 +4565,7 @@
       </p:sp>
       <p:sp>
         <p:nvSpPr>
-          <p:cNvPr id="100095" name="FactLab2"/>
+          <p:cNvPr id="100098" name="FactLab2"/>
           <p:cNvSpPr txBox="1"/>
           <p:nvPr/>
         </p:nvSpPr>
@@ -4484,7 +4604,7 @@
       </p:sp>
       <p:sp>
         <p:nvSpPr>
-          <p:cNvPr id="100096" name="FactBody2"/>
+          <p:cNvPr id="100099" name="FactBody2"/>
           <p:cNvSpPr txBox="1"/>
           <p:nvPr/>
         </p:nvSpPr>
@@ -4523,7 +4643,7 @@
       </p:sp>
       <p:sp>
         <p:nvSpPr>
-          <p:cNvPr id="100097" name="FactLab3"/>
+          <p:cNvPr id="100100" name="FactLab3"/>
           <p:cNvSpPr txBox="1"/>
           <p:nvPr/>
         </p:nvSpPr>
@@ -4562,7 +4682,7 @@
       </p:sp>
       <p:sp>
         <p:nvSpPr>
-          <p:cNvPr id="100098" name="FactBody3"/>
+          <p:cNvPr id="100101" name="FactBody3"/>
           <p:cNvSpPr txBox="1"/>
           <p:nvPr/>
         </p:nvSpPr>
@@ -4623,7 +4743,7 @@
       <p:grpSpPr/>
       <p:sp>
         <p:nvSpPr>
-          <p:cNvPr id="100099" name="Eyebrow"/>
+          <p:cNvPr id="100102" name="Eyebrow"/>
           <p:cNvSpPr txBox="1"/>
           <p:nvPr/>
         </p:nvSpPr>
@@ -4655,14 +4775,14 @@
                 <a:latin typeface="Consolas"/>
                 <a:ea typeface="Consolas"/>
               </a:rPr>
-              <a:t>04 / 05   ·   DEMO  ·  THE RUNNING APP</a:t>
-            </a:r>
-          </a:p>
-        </p:txBody>
-      </p:sp>
-      <p:sp>
-        <p:nvSpPr>
-          <p:cNvPr id="100100" name="Motif1"/>
+              <a:t>04 / 05   ·   DEMO  ·  THE LIVE APP</a:t>
+            </a:r>
+          </a:p>
+        </p:txBody>
+      </p:sp>
+      <p:sp>
+        <p:nvSpPr>
+          <p:cNvPr id="100103" name="Motif1"/>
           <p:cNvSpPr/>
           <p:nvPr/>
         </p:nvSpPr>
@@ -4689,7 +4809,7 @@
       </p:sp>
       <p:sp>
         <p:nvSpPr>
-          <p:cNvPr id="100101" name="Motif2"/>
+          <p:cNvPr id="100104" name="Motif2"/>
           <p:cNvSpPr/>
           <p:nvPr/>
         </p:nvSpPr>
@@ -4716,7 +4836,7 @@
       </p:sp>
       <p:sp>
         <p:nvSpPr>
-          <p:cNvPr id="100102" name="Motif3"/>
+          <p:cNvPr id="100105" name="Motif3"/>
           <p:cNvSpPr/>
           <p:nvPr/>
         </p:nvSpPr>
@@ -4743,7 +4863,7 @@
       </p:sp>
       <p:sp>
         <p:nvSpPr>
-          <p:cNvPr id="100103" name="Title"/>
+          <p:cNvPr id="100106" name="Title"/>
           <p:cNvSpPr txBox="1"/>
           <p:nvPr/>
         </p:nvSpPr>
@@ -4782,7 +4902,7 @@
       </p:sp>
       <p:sp>
         <p:nvSpPr>
-          <p:cNvPr id="100104" name="Footer"/>
+          <p:cNvPr id="100107" name="Footer"/>
           <p:cNvSpPr txBox="1"/>
           <p:nvPr/>
         </p:nvSpPr>
@@ -4821,7 +4941,7 @@
       </p:sp>
       <p:sp>
         <p:nvSpPr>
-          <p:cNvPr id="100105" name="ShotLab1"/>
+          <p:cNvPr id="100108" name="ShotLab1"/>
           <p:cNvSpPr txBox="1"/>
           <p:nvPr/>
         </p:nvSpPr>
@@ -4860,7 +4980,7 @@
       </p:sp>
       <p:sp>
         <p:nvSpPr>
-          <p:cNvPr id="100106" name="AppFrame1"/>
+          <p:cNvPr id="100109" name="AppFrame1"/>
           <p:cNvSpPr/>
           <p:nvPr/>
         </p:nvSpPr>
@@ -4889,14 +5009,14 @@
       </p:sp>
       <p:pic>
         <p:nvPicPr>
-          <p:cNvPr id="100107" name="Picture 1" descr="The running app answering 'What is the percentage of long haul flights out of Anchorage airport?': 2.7% of class F departures are Long-haul Flights; the Mission panel shows route_mix donuts at 2.7%, 6.2% and 29.5% and Data Confidence High"/>
+          <p:cNvPr id="100110" name="Picture 1" descr="The live app answering 'What is the percentage of long haul flights out of Anchorage airport?': 2.7% of class F departures are Long-haul Flights; the Mission panel shows route_mix donuts at 2.7%, 6.2% and 29.5% and Data Confidence High"/>
           <p:cNvPicPr>
             <a:picLocks xmlns:a="http://schemas.openxmlformats.org/drawingml/2006/main" noChangeAspect="1"/>
           </p:cNvPicPr>
           <p:nvPr/>
         </p:nvPicPr>
         <p:blipFill>
-          <a:blip xmlns:r="http://schemas.openxmlformats.org/officeDocument/2006/relationships" xmlns:a="http://schemas.openxmlformats.org/drawingml/2006/main" r:embed="Rcd22b6b09f304cf9"/>
+          <a:blip xmlns:r="http://schemas.openxmlformats.org/officeDocument/2006/relationships" xmlns:a="http://schemas.openxmlformats.org/drawingml/2006/main" r:embed="R48a009c55d1e4429"/>
           <a:stretch xmlns:a="http://schemas.openxmlformats.org/drawingml/2006/main">
             <a:fillRect/>
           </a:stretch>
@@ -4913,14 +5033,14 @@
       </p:pic>
       <p:sp>
         <p:nvSpPr>
-          <p:cNvPr id="100108" name="ShotCap1"/>
-          <p:cNvSpPr txBox="1"/>
-          <p:nvPr/>
-        </p:nvSpPr>
-        <p:spPr>
-          <a:xfrm xmlns:a="http://schemas.openxmlformats.org/drawingml/2006/main">
-            <a:off x="540000" y="5272560"/>
-            <a:ext cx="5411880" cy="864000"/>
+          <p:cNvPr id="100111" name="ShotCap1"/>
+          <p:cNvSpPr txBox="1"/>
+          <p:nvPr/>
+        </p:nvSpPr>
+        <p:spPr>
+          <a:xfrm xmlns:a="http://schemas.openxmlformats.org/drawingml/2006/main">
+            <a:off x="540000" y="5254560"/>
+            <a:ext cx="5411880" cy="720000"/>
           </a:xfrm>
           <a:prstGeom xmlns:a="http://schemas.openxmlformats.org/drawingml/2006/main" prst="rect">
             <a:avLst/>
@@ -4945,14 +5065,14 @@
                 <a:latin typeface="Arial"/>
                 <a:ea typeface="Arial"/>
               </a:rPr>
-              <a:t>2.7% of scheduled passenger departures are Long-haul (6.2% passenger-weighted, 29.5% cargo-inclusive). Mission panel: route_mix donuts and table, Data Confidence High.</a:t>
-            </a:r>
-          </a:p>
-        </p:txBody>
-      </p:sp>
-      <p:sp>
-        <p:nvSpPr>
-          <p:cNvPr id="100109" name="ShotLab2"/>
+              <a:t>2.7% of scheduled passenger departures are Long-haul; 6.2% passenger-weighted, 29.5% cargo-inclusive. Evidence: route_mix donuts, Data Confidence High.</a:t>
+            </a:r>
+          </a:p>
+        </p:txBody>
+      </p:sp>
+      <p:sp>
+        <p:nvSpPr>
+          <p:cNvPr id="100112" name="ShotLab2"/>
           <p:cNvSpPr txBox="1"/>
           <p:nvPr/>
         </p:nvSpPr>
@@ -4991,7 +5111,7 @@
       </p:sp>
       <p:sp>
         <p:nvSpPr>
-          <p:cNvPr id="100110" name="AppFrame2"/>
+          <p:cNvPr id="100113" name="AppFrame2"/>
           <p:cNvSpPr/>
           <p:nvPr/>
         </p:nvSpPr>
@@ -5020,14 +5140,14 @@
       </p:sp>
       <p:pic>
         <p:nvPicPr>
-          <p:cNvPr id="100111" name="Picture 2" descr="The running app answering 'Which airports in New England are strong candidates for terminal expansion?': a ranking table led by BOS 73.1, BGR 72.4 and BTV 71.9; the Mission panel shows rank_airports Pillar bars and the score table, Data Confidence Medium"/>
+          <p:cNvPr id="100114" name="Picture 2" descr="The live app answering 'Which airports in New England are strong candidates for terminal expansion?': the top 10 of 16 ranked airports, with BOS, BGR and BTV named the strongest candidates; the Mission panel shows rank_airports Pillar bars and the score table led by BOS 73.1 and BGR 72.4, Data Confidence Medium"/>
           <p:cNvPicPr>
             <a:picLocks xmlns:a="http://schemas.openxmlformats.org/drawingml/2006/main" noChangeAspect="1"/>
           </p:cNvPicPr>
           <p:nvPr/>
         </p:nvPicPr>
         <p:blipFill>
-          <a:blip xmlns:r="http://schemas.openxmlformats.org/officeDocument/2006/relationships" xmlns:a="http://schemas.openxmlformats.org/drawingml/2006/main" r:embed="R4f960e65d7b14c3f"/>
+          <a:blip xmlns:r="http://schemas.openxmlformats.org/officeDocument/2006/relationships" xmlns:a="http://schemas.openxmlformats.org/drawingml/2006/main" r:embed="R7b18a99475ef4535"/>
           <a:stretch xmlns:a="http://schemas.openxmlformats.org/drawingml/2006/main">
             <a:fillRect/>
           </a:stretch>
@@ -5044,14 +5164,14 @@
       </p:pic>
       <p:sp>
         <p:nvSpPr>
-          <p:cNvPr id="100112" name="ShotCap2"/>
-          <p:cNvSpPr txBox="1"/>
-          <p:nvPr/>
-        </p:nvSpPr>
-        <p:spPr>
-          <a:xfrm xmlns:a="http://schemas.openxmlformats.org/drawingml/2006/main">
-            <a:off x="6240240" y="5272560"/>
-            <a:ext cx="5411880" cy="864000"/>
+          <p:cNvPr id="100115" name="ShotCap2"/>
+          <p:cNvSpPr txBox="1"/>
+          <p:nvPr/>
+        </p:nvSpPr>
+        <p:spPr>
+          <a:xfrm xmlns:a="http://schemas.openxmlformats.org/drawingml/2006/main">
+            <a:off x="6240240" y="5254560"/>
+            <a:ext cx="5411880" cy="720000"/>
           </a:xfrm>
           <a:prstGeom xmlns:a="http://schemas.openxmlformats.org/drawingml/2006/main" prst="rect">
             <a:avLst/>
@@ -5076,7 +5196,127 @@
                 <a:latin typeface="Arial"/>
                 <a:ea typeface="Arial"/>
               </a:rPr>
-              <a:t>BOS 73.1, BGR 72.4 and BTV 71.9 lead 16 ranked airports. Mission panel: rank_airports Pillar bars and score table, Data Confidence Medium (HVN and PSM Provisional).</a:t>
+              <a:t>BOS 73.1, BGR 72.4 and BTV 71.9 lead 16 ranked airports. Evidence: rank_airports Pillar bars, Data Confidence Medium (HVN and PSM Provisional).</a:t>
+            </a:r>
+          </a:p>
+        </p:txBody>
+      </p:sp>
+      <p:sp>
+        <p:nvSpPr>
+          <p:cNvPr id="100116" name="LiveLabel"/>
+          <p:cNvSpPr txBox="1"/>
+          <p:nvPr/>
+        </p:nvSpPr>
+        <p:spPr>
+          <a:xfrm xmlns:a="http://schemas.openxmlformats.org/drawingml/2006/main">
+            <a:off x="540000" y="6120000"/>
+            <a:ext cx="1044000" cy="216000"/>
+          </a:xfrm>
+          <a:prstGeom xmlns:a="http://schemas.openxmlformats.org/drawingml/2006/main" prst="rect">
+            <a:avLst/>
+          </a:prstGeom>
+          <a:noFill xmlns:a="http://schemas.openxmlformats.org/drawingml/2006/main"/>
+          <a:ln xmlns:a="http://schemas.openxmlformats.org/drawingml/2006/main">
+            <a:noFill/>
+          </a:ln>
+        </p:spPr>
+        <p:txBody>
+          <a:bodyPr xmlns:a="http://schemas.openxmlformats.org/drawingml/2006/main" lIns="0" tIns="0" rIns="0" bIns="0" anchor="ctr">
+            <a:noAutofit/>
+          </a:bodyPr>
+          <a:lstStyle xmlns:a="http://schemas.openxmlformats.org/drawingml/2006/main"/>
+          <a:p xmlns:a="http://schemas.openxmlformats.org/drawingml/2006/main">
+            <a:pPr algn="l"/>
+            <a:r>
+              <a:rPr lang="en-US" sz="1100" b="0">
+                <a:solidFill>
+                  <a:srgbClr val="66645E"/>
+                </a:solidFill>
+                <a:latin typeface="Consolas"/>
+                <a:ea typeface="Consolas"/>
+              </a:rPr>
+              <a:t>LIVE DEMO</a:t>
+            </a:r>
+          </a:p>
+        </p:txBody>
+      </p:sp>
+      <p:sp>
+        <p:nvSpPr>
+          <p:cNvPr id="100117" name="LiveUrl">
+            <a:hlinkClick xmlns:r="http://schemas.openxmlformats.org/officeDocument/2006/relationships" xmlns:a="http://schemas.openxmlformats.org/drawingml/2006/main" r:id="R60001fbd5e484895"/>
+          </p:cNvPr>
+          <p:cNvSpPr txBox="1"/>
+          <p:nvPr/>
+        </p:nvSpPr>
+        <p:spPr>
+          <a:xfrm xmlns:a="http://schemas.openxmlformats.org/drawingml/2006/main">
+            <a:off x="1584000" y="6120000"/>
+            <a:ext cx="4824000" cy="216000"/>
+          </a:xfrm>
+          <a:prstGeom xmlns:a="http://schemas.openxmlformats.org/drawingml/2006/main" prst="rect">
+            <a:avLst/>
+          </a:prstGeom>
+          <a:noFill xmlns:a="http://schemas.openxmlformats.org/drawingml/2006/main"/>
+          <a:ln xmlns:a="http://schemas.openxmlformats.org/drawingml/2006/main">
+            <a:noFill/>
+          </a:ln>
+        </p:spPr>
+        <p:txBody>
+          <a:bodyPr xmlns:a="http://schemas.openxmlformats.org/drawingml/2006/main" lIns="0" tIns="0" rIns="0" bIns="0" anchor="ctr">
+            <a:noAutofit/>
+          </a:bodyPr>
+          <a:lstStyle xmlns:a="http://schemas.openxmlformats.org/drawingml/2006/main"/>
+          <a:p xmlns:a="http://schemas.openxmlformats.org/drawingml/2006/main">
+            <a:pPr algn="l"/>
+            <a:r>
+              <a:rPr lang="en-US" sz="1300" b="1">
+                <a:solidFill>
+                  <a:srgbClr val="1B1A17"/>
+                </a:solidFill>
+                <a:latin typeface="Consolas"/>
+                <a:ea typeface="Consolas"/>
+                <a:hlinkClick xmlns:r="http://schemas.openxmlformats.org/officeDocument/2006/relationships" r:id="R60001fbd5e484895"/>
+              </a:rPr>
+              <a:t>https://airport-investment-agent-n37j.onrender.com</a:t>
+            </a:r>
+          </a:p>
+        </p:txBody>
+      </p:sp>
+      <p:sp>
+        <p:nvSpPr>
+          <p:cNvPr id="100118" name="LiveNote"/>
+          <p:cNvSpPr txBox="1"/>
+          <p:nvPr/>
+        </p:nvSpPr>
+        <p:spPr>
+          <a:xfrm xmlns:a="http://schemas.openxmlformats.org/drawingml/2006/main">
+            <a:off x="6264000" y="6120000"/>
+            <a:ext cx="5388120" cy="216000"/>
+          </a:xfrm>
+          <a:prstGeom xmlns:a="http://schemas.openxmlformats.org/drawingml/2006/main" prst="rect">
+            <a:avLst/>
+          </a:prstGeom>
+          <a:noFill xmlns:a="http://schemas.openxmlformats.org/drawingml/2006/main"/>
+          <a:ln xmlns:a="http://schemas.openxmlformats.org/drawingml/2006/main">
+            <a:noFill/>
+          </a:ln>
+        </p:spPr>
+        <p:txBody>
+          <a:bodyPr xmlns:a="http://schemas.openxmlformats.org/drawingml/2006/main" lIns="0" tIns="0" rIns="0" bIns="0" anchor="ctr">
+            <a:noAutofit/>
+          </a:bodyPr>
+          <a:lstStyle xmlns:a="http://schemas.openxmlformats.org/drawingml/2006/main"/>
+          <a:p xmlns:a="http://schemas.openxmlformats.org/drawingml/2006/main">
+            <a:pPr algn="l"/>
+            <a:r>
+              <a:rPr lang="en-US" sz="1300" b="0">
+                <a:solidFill>
+                  <a:srgbClr val="66645E"/>
+                </a:solidFill>
+                <a:latin typeface="Arial"/>
+                <a:ea typeface="Arial"/>
+              </a:rPr>
+              <a:t>Asked live, 2026-10-22  ·  access code on request</a:t>
             </a:r>
           </a:p>
         </p:txBody>
@@ -5105,7 +5345,7 @@
       <p:grpSpPr/>
       <p:sp>
         <p:nvSpPr>
-          <p:cNvPr id="100113" name="Eyebrow"/>
+          <p:cNvPr id="100119" name="Eyebrow"/>
           <p:cNvSpPr txBox="1"/>
           <p:nvPr/>
         </p:nvSpPr>
@@ -5144,7 +5384,7 @@
       </p:sp>
       <p:sp>
         <p:nvSpPr>
-          <p:cNvPr id="100114" name="Motif1"/>
+          <p:cNvPr id="100120" name="Motif1"/>
           <p:cNvSpPr/>
           <p:nvPr/>
         </p:nvSpPr>
@@ -5171,7 +5411,7 @@
       </p:sp>
       <p:sp>
         <p:nvSpPr>
-          <p:cNvPr id="100115" name="Motif2"/>
+          <p:cNvPr id="100121" name="Motif2"/>
           <p:cNvSpPr/>
           <p:nvPr/>
         </p:nvSpPr>
@@ -5198,7 +5438,7 @@
       </p:sp>
       <p:sp>
         <p:nvSpPr>
-          <p:cNvPr id="100116" name="Motif3"/>
+          <p:cNvPr id="100122" name="Motif3"/>
           <p:cNvSpPr/>
           <p:nvPr/>
         </p:nvSpPr>
@@ -5225,7 +5465,7 @@
       </p:sp>
       <p:sp>
         <p:nvSpPr>
-          <p:cNvPr id="100117" name="Title"/>
+          <p:cNvPr id="100123" name="Title"/>
           <p:cNvSpPr txBox="1"/>
           <p:nvPr/>
         </p:nvSpPr>
@@ -5264,7 +5504,7 @@
       </p:sp>
       <p:sp>
         <p:nvSpPr>
-          <p:cNvPr id="100118" name="Footer"/>
+          <p:cNvPr id="100124" name="Footer"/>
           <p:cNvSpPr txBox="1"/>
           <p:nvPr/>
         </p:nvSpPr>
@@ -5303,7 +5543,7 @@
       </p:sp>
       <p:sp>
         <p:nvSpPr>
-          <p:cNvPr id="100119" name="Col1"/>
+          <p:cNvPr id="100125" name="Col1"/>
           <p:cNvSpPr/>
           <p:nvPr/>
         </p:nvSpPr>
@@ -5332,7 +5572,7 @@
       </p:sp>
       <p:sp>
         <p:nvSpPr>
-          <p:cNvPr id="100120" name="ColBand1"/>
+          <p:cNvPr id="100126" name="ColBand1"/>
           <p:cNvSpPr/>
           <p:nvPr/>
         </p:nvSpPr>
@@ -5359,7 +5599,7 @@
       </p:sp>
       <p:sp>
         <p:nvSpPr>
-          <p:cNvPr id="100121" name="ColLab1"/>
+          <p:cNvPr id="100127" name="ColLab1"/>
           <p:cNvSpPr txBox="1"/>
           <p:nvPr/>
         </p:nvSpPr>
@@ -5398,7 +5638,7 @@
       </p:sp>
       <p:sp>
         <p:nvSpPr>
-          <p:cNvPr id="100122" name="ColBody1"/>
+          <p:cNvPr id="100128" name="ColBody1"/>
           <p:cNvSpPr txBox="1"/>
           <p:nvPr/>
         </p:nvSpPr>
@@ -5522,7 +5762,7 @@
       </p:sp>
       <p:sp>
         <p:nvSpPr>
-          <p:cNvPr id="100123" name="Col2"/>
+          <p:cNvPr id="100129" name="Col2"/>
           <p:cNvSpPr/>
           <p:nvPr/>
         </p:nvSpPr>
@@ -5551,7 +5791,7 @@
       </p:sp>
       <p:sp>
         <p:nvSpPr>
-          <p:cNvPr id="100124" name="ColBand2"/>
+          <p:cNvPr id="100130" name="ColBand2"/>
           <p:cNvSpPr/>
           <p:nvPr/>
         </p:nvSpPr>
@@ -5578,7 +5818,7 @@
       </p:sp>
       <p:sp>
         <p:nvSpPr>
-          <p:cNvPr id="100125" name="ColLab2"/>
+          <p:cNvPr id="100131" name="ColLab2"/>
           <p:cNvSpPr txBox="1"/>
           <p:nvPr/>
         </p:nvSpPr>
@@ -5617,7 +5857,7 @@
       </p:sp>
       <p:sp>
         <p:nvSpPr>
-          <p:cNvPr id="100126" name="ColBody2"/>
+          <p:cNvPr id="100132" name="ColBody2"/>
           <p:cNvSpPr txBox="1"/>
           <p:nvPr/>
         </p:nvSpPr>
@@ -5716,7 +5956,7 @@
       </p:sp>
       <p:sp>
         <p:nvSpPr>
-          <p:cNvPr id="100127" name="Col3"/>
+          <p:cNvPr id="100133" name="Col3"/>
           <p:cNvSpPr/>
           <p:nvPr/>
         </p:nvSpPr>
@@ -5745,7 +5985,7 @@
       </p:sp>
       <p:sp>
         <p:nvSpPr>
-          <p:cNvPr id="100128" name="ColBand3"/>
+          <p:cNvPr id="100134" name="ColBand3"/>
           <p:cNvSpPr/>
           <p:nvPr/>
         </p:nvSpPr>
@@ -5772,7 +6012,7 @@
       </p:sp>
       <p:sp>
         <p:nvSpPr>
-          <p:cNvPr id="100129" name="ColLab3"/>
+          <p:cNvPr id="100135" name="ColLab3"/>
           <p:cNvSpPr txBox="1"/>
           <p:nvPr/>
         </p:nvSpPr>
@@ -5811,7 +6051,7 @@
       </p:sp>
       <p:sp>
         <p:nvSpPr>
-          <p:cNvPr id="100130" name="ColBody3"/>
+          <p:cNvPr id="100136" name="ColBody3"/>
           <p:cNvSpPr txBox="1"/>
           <p:nvPr/>
         </p:nvSpPr>
@@ -5973,10 +6213,10 @@
         <a:srgbClr val="70AD47"/>
       </a:accent6>
       <a:hlink>
-        <a:srgbClr val="0563C1"/>
+        <a:srgbClr val="1B1A17"/>
       </a:hlink>
       <a:folHlink>
-        <a:srgbClr val="954F72"/>
+        <a:srgbClr val="1B1A17"/>
       </a:folHlink>
     </a:clrScheme>
     <a:fontScheme name="Office">

</xml_diff>

<commit_message>
docs(deck): retake the G1 shot after the table fix, so slide 4 shows ranks 1-7
Asked once more on the live site (51c7439 deployed); rebuilt with OfficeCLI 1.0.158:
validate passes, view issues reports 0, all 5 slides rendered and checked.

Co-Authored-By: Claude Opus 5.5 <noreply@anthropic.com>
</commit_message>
<xml_diff>
--- a/docs/deck.pptx
+++ b/docs/deck.pptx
@@ -5,14 +5,14 @@
     <p:sldMasterId xmlns:r="http://schemas.openxmlformats.org/officeDocument/2006/relationships" id="2147483648" r:id="rId1"/>
   </p:sldMasterIdLst>
   <p:notesMasterIdLst>
-    <p:notesMasterId r:id="R221887f790b94617"/>
+    <p:notesMasterId r:id="R21c327ae2d2042d1"/>
   </p:notesMasterIdLst>
   <p:sldIdLst>
-    <p:sldId id="256" r:id="R3fb088fe38c14260"/>
-    <p:sldId id="257" r:id="Re59fb7b316f0415c"/>
-    <p:sldId id="258" r:id="R63b556d6f8164805"/>
-    <p:sldId id="259" r:id="R0318ca71d2484bc2"/>
-    <p:sldId id="260" r:id="R367d196017ff44eb"/>
+    <p:sldId id="256" r:id="R6464cf75a22d4eae"/>
+    <p:sldId id="257" r:id="Rf1ec42b660bc407a"/>
+    <p:sldId id="258" r:id="R17986ca095b340fd"/>
+    <p:sldId id="259" r:id="Rf4cd8034a36e4b24"/>
+    <p:sldId id="260" r:id="R654beb57f2b94f6d"/>
   </p:sldIdLst>
   <p:sldSz cx="12192000" cy="6858000"/>
   <p:notesSz cx="6858000" cy="9144000"/>
@@ -2035,7 +2035,7 @@
       <p:sp>
         <p:nvSpPr>
           <p:cNvPr id="100029" name="LiveUrl">
-            <a:hlinkClick xmlns:r="http://schemas.openxmlformats.org/officeDocument/2006/relationships" xmlns:a="http://schemas.openxmlformats.org/drawingml/2006/main" r:id="Re5ecb4acb1e8451d"/>
+            <a:hlinkClick xmlns:r="http://schemas.openxmlformats.org/officeDocument/2006/relationships" xmlns:a="http://schemas.openxmlformats.org/drawingml/2006/main" r:id="R53fbfd94c8224858"/>
           </p:cNvPr>
           <p:cNvSpPr txBox="1"/>
           <p:nvPr/>
@@ -2067,7 +2067,7 @@
                 </a:solidFill>
                 <a:latin typeface="Consolas"/>
                 <a:ea typeface="Consolas"/>
-                <a:hlinkClick xmlns:r="http://schemas.openxmlformats.org/officeDocument/2006/relationships" r:id="Re5ecb4acb1e8451d"/>
+                <a:hlinkClick xmlns:r="http://schemas.openxmlformats.org/officeDocument/2006/relationships" r:id="R53fbfd94c8224858"/>
               </a:rPr>
               <a:t>https://airport-investment-agent-n37j.onrender.com</a:t>
             </a:r>
@@ -4431,7 +4431,7 @@
           <p:nvPr/>
         </p:nvPicPr>
         <p:blipFill>
-          <a:blip xmlns:r="http://schemas.openxmlformats.org/officeDocument/2006/relationships" xmlns:a="http://schemas.openxmlformats.org/drawingml/2006/main" r:embed="R32b97ddeb7384ad7"/>
+          <a:blip xmlns:r="http://schemas.openxmlformats.org/officeDocument/2006/relationships" xmlns:a="http://schemas.openxmlformats.org/drawingml/2006/main" r:embed="Rbbfc5d03a83748be"/>
           <a:stretch xmlns:a="http://schemas.openxmlformats.org/drawingml/2006/main">
             <a:fillRect/>
           </a:stretch>
@@ -5016,7 +5016,7 @@
           <p:nvPr/>
         </p:nvPicPr>
         <p:blipFill>
-          <a:blip xmlns:r="http://schemas.openxmlformats.org/officeDocument/2006/relationships" xmlns:a="http://schemas.openxmlformats.org/drawingml/2006/main" r:embed="R48a009c55d1e4429"/>
+          <a:blip xmlns:r="http://schemas.openxmlformats.org/officeDocument/2006/relationships" xmlns:a="http://schemas.openxmlformats.org/drawingml/2006/main" r:embed="R38b77813ae694cd2"/>
           <a:stretch xmlns:a="http://schemas.openxmlformats.org/drawingml/2006/main">
             <a:fillRect/>
           </a:stretch>
@@ -5147,7 +5147,7 @@
           <p:nvPr/>
         </p:nvPicPr>
         <p:blipFill>
-          <a:blip xmlns:r="http://schemas.openxmlformats.org/officeDocument/2006/relationships" xmlns:a="http://schemas.openxmlformats.org/drawingml/2006/main" r:embed="R7b18a99475ef4535"/>
+          <a:blip xmlns:r="http://schemas.openxmlformats.org/officeDocument/2006/relationships" xmlns:a="http://schemas.openxmlformats.org/drawingml/2006/main" r:embed="Rce7e50fe11db46d3"/>
           <a:stretch xmlns:a="http://schemas.openxmlformats.org/drawingml/2006/main">
             <a:fillRect/>
           </a:stretch>
@@ -5243,7 +5243,7 @@
       <p:sp>
         <p:nvSpPr>
           <p:cNvPr id="100117" name="LiveUrl">
-            <a:hlinkClick xmlns:r="http://schemas.openxmlformats.org/officeDocument/2006/relationships" xmlns:a="http://schemas.openxmlformats.org/drawingml/2006/main" r:id="R60001fbd5e484895"/>
+            <a:hlinkClick xmlns:r="http://schemas.openxmlformats.org/officeDocument/2006/relationships" xmlns:a="http://schemas.openxmlformats.org/drawingml/2006/main" r:id="R37ac0c65449f430c"/>
           </p:cNvPr>
           <p:cNvSpPr txBox="1"/>
           <p:nvPr/>
@@ -5275,7 +5275,7 @@
                 </a:solidFill>
                 <a:latin typeface="Consolas"/>
                 <a:ea typeface="Consolas"/>
-                <a:hlinkClick xmlns:r="http://schemas.openxmlformats.org/officeDocument/2006/relationships" r:id="R60001fbd5e484895"/>
+                <a:hlinkClick xmlns:r="http://schemas.openxmlformats.org/officeDocument/2006/relationships" r:id="R37ac0c65449f430c"/>
               </a:rPr>
               <a:t>https://airport-investment-agent-n37j.onrender.com</a:t>
             </a:r>

</xml_diff>

<commit_message>
docs(deck): voice is built; slide 2 and slide 5 say so
Slide 2's chat box and notes mention the optional voice call over the same agent; slide 5 moves voice
from next steps to tradeoffs (one brain, a short pause), matching DESIGN.md. OfficeCLI 1.0.158:
validate passes, view issues reports 0, slides 2 and 5 rendered and checked.

Co-Authored-By: Claude Opus 5.5 <noreply@anthropic.com>
</commit_message>
<xml_diff>
--- a/docs/deck.pptx
+++ b/docs/deck.pptx
@@ -5,14 +5,14 @@
     <p:sldMasterId xmlns:r="http://schemas.openxmlformats.org/officeDocument/2006/relationships" id="2147483648" r:id="rId1"/>
   </p:sldMasterIdLst>
   <p:notesMasterIdLst>
-    <p:notesMasterId r:id="R21c327ae2d2042d1"/>
+    <p:notesMasterId r:id="Re41d78d1a0d44013"/>
   </p:notesMasterIdLst>
   <p:sldIdLst>
-    <p:sldId id="256" r:id="R6464cf75a22d4eae"/>
-    <p:sldId id="257" r:id="Rf1ec42b660bc407a"/>
-    <p:sldId id="258" r:id="R17986ca095b340fd"/>
-    <p:sldId id="259" r:id="Rf4cd8034a36e4b24"/>
-    <p:sldId id="260" r:id="R654beb57f2b94f6d"/>
+    <p:sldId id="256" r:id="R8f54d3d6313d47f0"/>
+    <p:sldId id="257" r:id="Rba3d70aa718f4076"/>
+    <p:sldId id="258" r:id="R492cd43cd60b4e99"/>
+    <p:sldId id="259" r:id="R57217b29c73d4558"/>
+    <p:sldId id="260" r:id="R2a8cacade07043fb"/>
   </p:sldIdLst>
   <p:sldSz cx="12192000" cy="6858000"/>
   <p:notesSz cx="6858000" cy="9144000"/>
@@ -530,7 +530,7 @@
           <a:p xmlns:a="http://schemas.openxmlformats.org/drawingml/2006/main">
             <a:r>
               <a:rPr lang="en-US"/>
-              <a:t>Left to right. Offline scripts build a dated Snapshot of FAA, BTS and Census data as Parquet; Live Signals are fetched at question time and never change a score. Deterministic tools compute every score, share and Forecast Gap. The Pydantic AI agent on Claude Sonnet 5.5 only picks tools, states Assumptions and explains. The chat shows the answer, and the Mission panel shows each tool's data as tables and charts so every figure can be checked. Every tool returns the same envelope, and a live number-grounding test fails if an answer quotes a number that is not in that run's tool results.</a:t>
+              <a:t>Left to right. Offline scripts build a dated Snapshot of FAA, BTS and Census data as Parquet; Live Signals are fetched at question time and never change a score. Deterministic tools compute every score, share and Forecast Gap. The Pydantic AI agent on Claude Sonnet 5.5 only picks tools, states Assumptions and explains. The chat shows the answer, and the Mission panel shows each tool's data as tables and charts so every figure can be checked. An optional voice call uses gpt-live-1 only to talk: it hands every question to the same agent, so voice and text cannot disagree on a number. Every tool returns the same envelope, and a live number-grounding test fails if an answer quotes a number that is not in that run's tool results.</a:t>
             </a:r>
           </a:p>
         </p:txBody>
@@ -695,7 +695,7 @@
           <a:p xmlns:a="http://schemas.openxmlformats.org/drawingml/2006/main">
             <a:r>
               <a:rPr lang="en-US"/>
-              <a:t>Tradeoffs: a dated Snapshot makes every score reproducible and the demo independent of API uptime, at the cost of staleness; Live Signals add evidence but never change a score. A geometric mean of percentiles penalises a weak Pillar, and median imputation has a known, disclosed bias. Pydantic AI runs the tool loop instead of a hand-written agent. Limitations: the score screens and does not prove profitability; percentiles favour small, fast-growing airports, as when doubling the growth weight lifts BID and WST into the New England top 10; delay data covers only reporting carriers' domestic flights. Next: backtest the weights against past terminal projects, add gate utilisation and ASPM data, schedule Snapshot refreshes, and build the designed voice call.</a:t>
+              <a:t>Tradeoffs: a dated Snapshot makes every score reproducible and the demo independent of API uptime, at the cost of staleness; Live Signals add evidence but never change a score. A geometric mean of percentiles penalises a weak Pillar, and median imputation has a known, disclosed bias. Pydantic AI runs the tool loop instead of a hand-written agent. Limitations: the score screens and does not prove profitability; percentiles favour small, fast-growing airports, as when doubling the growth weight lifts BID and WST into the New England top 10; delay data covers only reporting carriers' domestic flights. Next: backtest the weights against past terminal projects, add gate utilisation and ASPM data, and schedule Snapshot refreshes. Voice is a shell over the same agent: one brain, at the cost of a short pause while the numbers are pulled.</a:t>
             </a:r>
           </a:p>
         </p:txBody>
@@ -2035,7 +2035,7 @@
       <p:sp>
         <p:nvSpPr>
           <p:cNvPr id="100029" name="LiveUrl">
-            <a:hlinkClick xmlns:r="http://schemas.openxmlformats.org/officeDocument/2006/relationships" xmlns:a="http://schemas.openxmlformats.org/drawingml/2006/main" r:id="R53fbfd94c8224858"/>
+            <a:hlinkClick xmlns:r="http://schemas.openxmlformats.org/officeDocument/2006/relationships" xmlns:a="http://schemas.openxmlformats.org/drawingml/2006/main" r:id="R8d875f32c5b44bc8"/>
           </p:cNvPr>
           <p:cNvSpPr txBox="1"/>
           <p:nvPr/>
@@ -2067,7 +2067,7 @@
                 </a:solidFill>
                 <a:latin typeface="Consolas"/>
                 <a:ea typeface="Consolas"/>
-                <a:hlinkClick xmlns:r="http://schemas.openxmlformats.org/officeDocument/2006/relationships" r:id="R53fbfd94c8224858"/>
+                <a:hlinkClick xmlns:r="http://schemas.openxmlformats.org/officeDocument/2006/relationships" r:id="R8d875f32c5b44bc8"/>
               </a:rPr>
               <a:t>https://airport-investment-agent-n37j.onrender.com</a:t>
             </a:r>
@@ -2999,7 +2999,7 @@
                 <a:latin typeface="Arial"/>
                 <a:ea typeface="Arial"/>
               </a:rPr>
-              <a:t>Next.js chat. The Mission panel shows Progress, Evidence tables and charts, and Trace.</a:t>
+              <a:t>Next.js chat, or a voice call over the same agent. The Mission panel shows the Evidence.</a:t>
             </a:r>
           </a:p>
         </p:txBody>
@@ -4431,7 +4431,7 @@
           <p:nvPr/>
         </p:nvPicPr>
         <p:blipFill>
-          <a:blip xmlns:r="http://schemas.openxmlformats.org/officeDocument/2006/relationships" xmlns:a="http://schemas.openxmlformats.org/drawingml/2006/main" r:embed="Rbbfc5d03a83748be"/>
+          <a:blip xmlns:r="http://schemas.openxmlformats.org/officeDocument/2006/relationships" xmlns:a="http://schemas.openxmlformats.org/drawingml/2006/main" r:embed="Re63abe4448f846cb"/>
           <a:stretch xmlns:a="http://schemas.openxmlformats.org/drawingml/2006/main">
             <a:fillRect/>
           </a:stretch>
@@ -5016,7 +5016,7 @@
           <p:nvPr/>
         </p:nvPicPr>
         <p:blipFill>
-          <a:blip xmlns:r="http://schemas.openxmlformats.org/officeDocument/2006/relationships" xmlns:a="http://schemas.openxmlformats.org/drawingml/2006/main" r:embed="R38b77813ae694cd2"/>
+          <a:blip xmlns:r="http://schemas.openxmlformats.org/officeDocument/2006/relationships" xmlns:a="http://schemas.openxmlformats.org/drawingml/2006/main" r:embed="Rc3532052a0c446bb"/>
           <a:stretch xmlns:a="http://schemas.openxmlformats.org/drawingml/2006/main">
             <a:fillRect/>
           </a:stretch>
@@ -5147,7 +5147,7 @@
           <p:nvPr/>
         </p:nvPicPr>
         <p:blipFill>
-          <a:blip xmlns:r="http://schemas.openxmlformats.org/officeDocument/2006/relationships" xmlns:a="http://schemas.openxmlformats.org/drawingml/2006/main" r:embed="Rce7e50fe11db46d3"/>
+          <a:blip xmlns:r="http://schemas.openxmlformats.org/officeDocument/2006/relationships" xmlns:a="http://schemas.openxmlformats.org/drawingml/2006/main" r:embed="R23deef3e93494e04"/>
           <a:stretch xmlns:a="http://schemas.openxmlformats.org/drawingml/2006/main">
             <a:fillRect/>
           </a:stretch>
@@ -5243,7 +5243,7 @@
       <p:sp>
         <p:nvSpPr>
           <p:cNvPr id="100117" name="LiveUrl">
-            <a:hlinkClick xmlns:r="http://schemas.openxmlformats.org/officeDocument/2006/relationships" xmlns:a="http://schemas.openxmlformats.org/drawingml/2006/main" r:id="R37ac0c65449f430c"/>
+            <a:hlinkClick xmlns:r="http://schemas.openxmlformats.org/officeDocument/2006/relationships" xmlns:a="http://schemas.openxmlformats.org/drawingml/2006/main" r:id="R1338f2d45e8a42ad"/>
           </p:cNvPr>
           <p:cNvSpPr txBox="1"/>
           <p:nvPr/>
@@ -5275,7 +5275,7 @@
                 </a:solidFill>
                 <a:latin typeface="Consolas"/>
                 <a:ea typeface="Consolas"/>
-                <a:hlinkClick xmlns:r="http://schemas.openxmlformats.org/officeDocument/2006/relationships" r:id="R37ac0c65449f430c"/>
+                <a:hlinkClick xmlns:r="http://schemas.openxmlformats.org/officeDocument/2006/relationships" r:id="R1338f2d45e8a42ad"/>
               </a:rPr>
               <a:t>https://airport-investment-agent-n37j.onrender.com</a:t>
             </a:r>
@@ -5745,7 +5745,7 @@
                   <a:srgbClr val="1B1A17"/>
                 </a:solidFill>
               </a:rPr>
-              <a:t>Proven harness</a:t>
+              <a:t>Voice delegates to the agent</a:t>
             </a:r>
           </a:p>
           <a:p xmlns:a="http://schemas.openxmlformats.org/drawingml/2006/main">
@@ -5755,7 +5755,7 @@
                   <a:srgbClr val="66645E"/>
                 </a:solidFill>
               </a:rPr>
-              <a:t>Pydantic AI runs the tool loop; no hand-written agent loop.</a:t>
+              <a:t>One brain for voice and text; a short pause to pull the numbers.</a:t>
             </a:r>
           </a:p>
         </p:txBody>
@@ -6144,31 +6144,6 @@
                 </a:solidFill>
               </a:rPr>
               <a:t>so As-of Dates stay current.</a:t>
-            </a:r>
-          </a:p>
-          <a:p xmlns:a="http://schemas.openxmlformats.org/drawingml/2006/main">
-            <a:pPr>
-              <a:spcBef>
-                <a:spcPts val="1400"/>
-              </a:spcBef>
-            </a:pPr>
-            <a:r>
-              <a:rPr lang="en-US" sz="1600" b="1">
-                <a:solidFill>
-                  <a:srgbClr val="1B1A17"/>
-                </a:solidFill>
-              </a:rPr>
-              <a:t>Voice call</a:t>
-            </a:r>
-          </a:p>
-          <a:p xmlns:a="http://schemas.openxmlformats.org/drawingml/2006/main">
-            <a:r>
-              <a:rPr lang="en-US" sz="1600" b="0">
-                <a:solidFill>
-                  <a:srgbClr val="66645E"/>
-                </a:solidFill>
-              </a:rPr>
-              <a:t>designed over the same agent; not built.</a:t>
             </a:r>
           </a:p>
         </p:txBody>

</xml_diff>